<commit_message>
Site updated: 2021-04-02 14:45:01
</commit_message>
<xml_diff>
--- a/css/images/DIY banner.pptx
+++ b/css/images/DIY banner.pptx
@@ -2,19 +2,22 @@
 <file path=ppt/presentation.xml><?xml version="1.0" encoding="utf-8"?>
 <p:presentation xmlns:a="http://schemas.openxmlformats.org/drawingml/2006/main" xmlns:r="http://schemas.openxmlformats.org/officeDocument/2006/relationships" xmlns:p="http://schemas.openxmlformats.org/presentationml/2006/main" saveSubsetFonts="1">
   <p:sldMasterIdLst>
-    <p:sldMasterId id="2147483648" r:id="rId1"/>
+    <p:sldMasterId id="2147483684" r:id="rId1"/>
   </p:sldMasterIdLst>
+  <p:notesMasterIdLst>
+    <p:notesMasterId r:id="rId3"/>
+  </p:notesMasterIdLst>
   <p:sldIdLst>
     <p:sldId id="257" r:id="rId2"/>
   </p:sldIdLst>
-  <p:sldSz cx="12192000" cy="6858000"/>
+  <p:sldSz cx="7524750" cy="2897188"/>
   <p:notesSz cx="6858000" cy="9144000"/>
   <p:defaultTextStyle>
     <a:defPPr>
       <a:defRPr lang="zh-CN"/>
     </a:defPPr>
-    <a:lvl1pPr marL="0" algn="l" defTabSz="914400" rtl="0" eaLnBrk="1" latinLnBrk="0" hangingPunct="1">
-      <a:defRPr sz="1800" kern="1200">
+    <a:lvl1pPr marL="0" algn="l" defTabSz="383230" rtl="0" eaLnBrk="1" latinLnBrk="0" hangingPunct="1">
+      <a:defRPr sz="754" kern="1200">
         <a:solidFill>
           <a:schemeClr val="tx1"/>
         </a:solidFill>
@@ -23,8 +26,8 @@
         <a:cs typeface="+mn-cs"/>
       </a:defRPr>
     </a:lvl1pPr>
-    <a:lvl2pPr marL="457200" algn="l" defTabSz="914400" rtl="0" eaLnBrk="1" latinLnBrk="0" hangingPunct="1">
-      <a:defRPr sz="1800" kern="1200">
+    <a:lvl2pPr marL="191614" algn="l" defTabSz="383230" rtl="0" eaLnBrk="1" latinLnBrk="0" hangingPunct="1">
+      <a:defRPr sz="754" kern="1200">
         <a:solidFill>
           <a:schemeClr val="tx1"/>
         </a:solidFill>
@@ -33,8 +36,8 @@
         <a:cs typeface="+mn-cs"/>
       </a:defRPr>
     </a:lvl2pPr>
-    <a:lvl3pPr marL="914400" algn="l" defTabSz="914400" rtl="0" eaLnBrk="1" latinLnBrk="0" hangingPunct="1">
-      <a:defRPr sz="1800" kern="1200">
+    <a:lvl3pPr marL="383230" algn="l" defTabSz="383230" rtl="0" eaLnBrk="1" latinLnBrk="0" hangingPunct="1">
+      <a:defRPr sz="754" kern="1200">
         <a:solidFill>
           <a:schemeClr val="tx1"/>
         </a:solidFill>
@@ -43,8 +46,8 @@
         <a:cs typeface="+mn-cs"/>
       </a:defRPr>
     </a:lvl3pPr>
-    <a:lvl4pPr marL="1371600" algn="l" defTabSz="914400" rtl="0" eaLnBrk="1" latinLnBrk="0" hangingPunct="1">
-      <a:defRPr sz="1800" kern="1200">
+    <a:lvl4pPr marL="574844" algn="l" defTabSz="383230" rtl="0" eaLnBrk="1" latinLnBrk="0" hangingPunct="1">
+      <a:defRPr sz="754" kern="1200">
         <a:solidFill>
           <a:schemeClr val="tx1"/>
         </a:solidFill>
@@ -53,8 +56,8 @@
         <a:cs typeface="+mn-cs"/>
       </a:defRPr>
     </a:lvl4pPr>
-    <a:lvl5pPr marL="1828800" algn="l" defTabSz="914400" rtl="0" eaLnBrk="1" latinLnBrk="0" hangingPunct="1">
-      <a:defRPr sz="1800" kern="1200">
+    <a:lvl5pPr marL="766461" algn="l" defTabSz="383230" rtl="0" eaLnBrk="1" latinLnBrk="0" hangingPunct="1">
+      <a:defRPr sz="754" kern="1200">
         <a:solidFill>
           <a:schemeClr val="tx1"/>
         </a:solidFill>
@@ -63,8 +66,8 @@
         <a:cs typeface="+mn-cs"/>
       </a:defRPr>
     </a:lvl5pPr>
-    <a:lvl6pPr marL="2286000" algn="l" defTabSz="914400" rtl="0" eaLnBrk="1" latinLnBrk="0" hangingPunct="1">
-      <a:defRPr sz="1800" kern="1200">
+    <a:lvl6pPr marL="958075" algn="l" defTabSz="383230" rtl="0" eaLnBrk="1" latinLnBrk="0" hangingPunct="1">
+      <a:defRPr sz="754" kern="1200">
         <a:solidFill>
           <a:schemeClr val="tx1"/>
         </a:solidFill>
@@ -73,8 +76,8 @@
         <a:cs typeface="+mn-cs"/>
       </a:defRPr>
     </a:lvl6pPr>
-    <a:lvl7pPr marL="2743200" algn="l" defTabSz="914400" rtl="0" eaLnBrk="1" latinLnBrk="0" hangingPunct="1">
-      <a:defRPr sz="1800" kern="1200">
+    <a:lvl7pPr marL="1149691" algn="l" defTabSz="383230" rtl="0" eaLnBrk="1" latinLnBrk="0" hangingPunct="1">
+      <a:defRPr sz="754" kern="1200">
         <a:solidFill>
           <a:schemeClr val="tx1"/>
         </a:solidFill>
@@ -83,8 +86,8 @@
         <a:cs typeface="+mn-cs"/>
       </a:defRPr>
     </a:lvl7pPr>
-    <a:lvl8pPr marL="3200400" algn="l" defTabSz="914400" rtl="0" eaLnBrk="1" latinLnBrk="0" hangingPunct="1">
-      <a:defRPr sz="1800" kern="1200">
+    <a:lvl8pPr marL="1341305" algn="l" defTabSz="383230" rtl="0" eaLnBrk="1" latinLnBrk="0" hangingPunct="1">
+      <a:defRPr sz="754" kern="1200">
         <a:solidFill>
           <a:schemeClr val="tx1"/>
         </a:solidFill>
@@ -93,8 +96,8 @@
         <a:cs typeface="+mn-cs"/>
       </a:defRPr>
     </a:lvl8pPr>
-    <a:lvl9pPr marL="3657600" algn="l" defTabSz="914400" rtl="0" eaLnBrk="1" latinLnBrk="0" hangingPunct="1">
-      <a:defRPr sz="1800" kern="1200">
+    <a:lvl9pPr marL="1532921" algn="l" defTabSz="383230" rtl="0" eaLnBrk="1" latinLnBrk="0" hangingPunct="1">
+      <a:defRPr sz="754" kern="1200">
         <a:solidFill>
           <a:schemeClr val="tx1"/>
         </a:solidFill>
@@ -104,7 +107,483 @@
       </a:defRPr>
     </a:lvl9pPr>
   </p:defaultTextStyle>
+  <p:extLst>
+    <p:ext uri="{EFAFB233-063F-42B5-8137-9DF3F51BA10A}">
+      <p15:sldGuideLst xmlns:p15="http://schemas.microsoft.com/office/powerpoint/2012/main"/>
+    </p:ext>
+  </p:extLst>
 </p:presentation>
+</file>
+
+<file path=ppt/notesMasters/notesMaster1.xml><?xml version="1.0" encoding="utf-8"?>
+<p:notesMaster xmlns:a="http://schemas.openxmlformats.org/drawingml/2006/main" xmlns:r="http://schemas.openxmlformats.org/officeDocument/2006/relationships" xmlns:p="http://schemas.openxmlformats.org/presentationml/2006/main">
+  <p:cSld>
+    <p:bg>
+      <p:bgRef idx="1001">
+        <a:schemeClr val="bg1"/>
+      </p:bgRef>
+    </p:bg>
+    <p:spTree>
+      <p:nvGrpSpPr>
+        <p:cNvPr id="1" name=""/>
+        <p:cNvGrpSpPr/>
+        <p:nvPr/>
+      </p:nvGrpSpPr>
+      <p:grpSpPr>
+        <a:xfrm>
+          <a:off x="0" y="0"/>
+          <a:ext cx="0" cy="0"/>
+          <a:chOff x="0" y="0"/>
+          <a:chExt cx="0" cy="0"/>
+        </a:xfrm>
+      </p:grpSpPr>
+      <p:sp>
+        <p:nvSpPr>
+          <p:cNvPr id="2" name="页眉占位符 1"/>
+          <p:cNvSpPr>
+            <a:spLocks noGrp="1"/>
+          </p:cNvSpPr>
+          <p:nvPr>
+            <p:ph type="hdr" sz="quarter"/>
+          </p:nvPr>
+        </p:nvSpPr>
+        <p:spPr>
+          <a:xfrm>
+            <a:off x="0" y="0"/>
+            <a:ext cx="2971800" cy="458788"/>
+          </a:xfrm>
+          <a:prstGeom prst="rect">
+            <a:avLst/>
+          </a:prstGeom>
+        </p:spPr>
+        <p:txBody>
+          <a:bodyPr vert="horz" lIns="91440" tIns="45720" rIns="91440" bIns="45720" rtlCol="0"/>
+          <a:lstStyle>
+            <a:lvl1pPr algn="l">
+              <a:defRPr sz="1200"/>
+            </a:lvl1pPr>
+          </a:lstStyle>
+          <a:p>
+            <a:endParaRPr lang="zh-CN" altLang="en-US"/>
+          </a:p>
+        </p:txBody>
+      </p:sp>
+      <p:sp>
+        <p:nvSpPr>
+          <p:cNvPr id="3" name="日期占位符 2"/>
+          <p:cNvSpPr>
+            <a:spLocks noGrp="1"/>
+          </p:cNvSpPr>
+          <p:nvPr>
+            <p:ph type="dt" idx="1"/>
+          </p:nvPr>
+        </p:nvSpPr>
+        <p:spPr>
+          <a:xfrm>
+            <a:off x="3884613" y="0"/>
+            <a:ext cx="2971800" cy="458788"/>
+          </a:xfrm>
+          <a:prstGeom prst="rect">
+            <a:avLst/>
+          </a:prstGeom>
+        </p:spPr>
+        <p:txBody>
+          <a:bodyPr vert="horz" lIns="91440" tIns="45720" rIns="91440" bIns="45720" rtlCol="0"/>
+          <a:lstStyle>
+            <a:lvl1pPr algn="r">
+              <a:defRPr sz="1200"/>
+            </a:lvl1pPr>
+          </a:lstStyle>
+          <a:p>
+            <a:fld id="{CB773615-C70C-469C-8CED-74B9F62CB448}" type="datetimeFigureOut">
+              <a:rPr lang="zh-CN" altLang="en-US" smtClean="0"/>
+              <a:t>2021/04/02</a:t>
+            </a:fld>
+            <a:endParaRPr lang="zh-CN" altLang="en-US"/>
+          </a:p>
+        </p:txBody>
+      </p:sp>
+      <p:sp>
+        <p:nvSpPr>
+          <p:cNvPr id="4" name="幻灯片图像占位符 3"/>
+          <p:cNvSpPr>
+            <a:spLocks noGrp="1" noRot="1" noChangeAspect="1"/>
+          </p:cNvSpPr>
+          <p:nvPr>
+            <p:ph type="sldImg" idx="2"/>
+          </p:nvPr>
+        </p:nvSpPr>
+        <p:spPr>
+          <a:xfrm>
+            <a:off x="-577850" y="1143000"/>
+            <a:ext cx="8013700" cy="3086100"/>
+          </a:xfrm>
+          <a:prstGeom prst="rect">
+            <a:avLst/>
+          </a:prstGeom>
+          <a:noFill/>
+          <a:ln w="12700">
+            <a:solidFill>
+              <a:prstClr val="black"/>
+            </a:solidFill>
+          </a:ln>
+        </p:spPr>
+        <p:txBody>
+          <a:bodyPr vert="horz" lIns="91440" tIns="45720" rIns="91440" bIns="45720" rtlCol="0" anchor="ctr"/>
+          <a:lstStyle/>
+          <a:p>
+            <a:endParaRPr lang="zh-CN" altLang="en-US"/>
+          </a:p>
+        </p:txBody>
+      </p:sp>
+      <p:sp>
+        <p:nvSpPr>
+          <p:cNvPr id="5" name="备注占位符 4"/>
+          <p:cNvSpPr>
+            <a:spLocks noGrp="1"/>
+          </p:cNvSpPr>
+          <p:nvPr>
+            <p:ph type="body" sz="quarter" idx="3"/>
+          </p:nvPr>
+        </p:nvSpPr>
+        <p:spPr>
+          <a:xfrm>
+            <a:off x="685800" y="4400550"/>
+            <a:ext cx="5486400" cy="3600450"/>
+          </a:xfrm>
+          <a:prstGeom prst="rect">
+            <a:avLst/>
+          </a:prstGeom>
+        </p:spPr>
+        <p:txBody>
+          <a:bodyPr vert="horz" lIns="91440" tIns="45720" rIns="91440" bIns="45720" rtlCol="0"/>
+          <a:lstStyle/>
+          <a:p>
+            <a:pPr lvl="0"/>
+            <a:r>
+              <a:rPr lang="zh-CN" altLang="en-US" smtClean="0"/>
+              <a:t>编辑母版文本样式</a:t>
+            </a:r>
+          </a:p>
+          <a:p>
+            <a:pPr lvl="1"/>
+            <a:r>
+              <a:rPr lang="zh-CN" altLang="en-US" smtClean="0"/>
+              <a:t>第二级</a:t>
+            </a:r>
+          </a:p>
+          <a:p>
+            <a:pPr lvl="2"/>
+            <a:r>
+              <a:rPr lang="zh-CN" altLang="en-US" smtClean="0"/>
+              <a:t>第三级</a:t>
+            </a:r>
+          </a:p>
+          <a:p>
+            <a:pPr lvl="3"/>
+            <a:r>
+              <a:rPr lang="zh-CN" altLang="en-US" smtClean="0"/>
+              <a:t>第四级</a:t>
+            </a:r>
+          </a:p>
+          <a:p>
+            <a:pPr lvl="4"/>
+            <a:r>
+              <a:rPr lang="zh-CN" altLang="en-US" smtClean="0"/>
+              <a:t>第五级</a:t>
+            </a:r>
+            <a:endParaRPr lang="zh-CN" altLang="en-US"/>
+          </a:p>
+        </p:txBody>
+      </p:sp>
+      <p:sp>
+        <p:nvSpPr>
+          <p:cNvPr id="6" name="页脚占位符 5"/>
+          <p:cNvSpPr>
+            <a:spLocks noGrp="1"/>
+          </p:cNvSpPr>
+          <p:nvPr>
+            <p:ph type="ftr" sz="quarter" idx="4"/>
+          </p:nvPr>
+        </p:nvSpPr>
+        <p:spPr>
+          <a:xfrm>
+            <a:off x="0" y="8685213"/>
+            <a:ext cx="2971800" cy="458787"/>
+          </a:xfrm>
+          <a:prstGeom prst="rect">
+            <a:avLst/>
+          </a:prstGeom>
+        </p:spPr>
+        <p:txBody>
+          <a:bodyPr vert="horz" lIns="91440" tIns="45720" rIns="91440" bIns="45720" rtlCol="0" anchor="b"/>
+          <a:lstStyle>
+            <a:lvl1pPr algn="l">
+              <a:defRPr sz="1200"/>
+            </a:lvl1pPr>
+          </a:lstStyle>
+          <a:p>
+            <a:endParaRPr lang="zh-CN" altLang="en-US"/>
+          </a:p>
+        </p:txBody>
+      </p:sp>
+      <p:sp>
+        <p:nvSpPr>
+          <p:cNvPr id="7" name="灯片编号占位符 6"/>
+          <p:cNvSpPr>
+            <a:spLocks noGrp="1"/>
+          </p:cNvSpPr>
+          <p:nvPr>
+            <p:ph type="sldNum" sz="quarter" idx="5"/>
+          </p:nvPr>
+        </p:nvSpPr>
+        <p:spPr>
+          <a:xfrm>
+            <a:off x="3884613" y="8685213"/>
+            <a:ext cx="2971800" cy="458787"/>
+          </a:xfrm>
+          <a:prstGeom prst="rect">
+            <a:avLst/>
+          </a:prstGeom>
+        </p:spPr>
+        <p:txBody>
+          <a:bodyPr vert="horz" lIns="91440" tIns="45720" rIns="91440" bIns="45720" rtlCol="0" anchor="b"/>
+          <a:lstStyle>
+            <a:lvl1pPr algn="r">
+              <a:defRPr sz="1200"/>
+            </a:lvl1pPr>
+          </a:lstStyle>
+          <a:p>
+            <a:fld id="{700D12A1-17D8-4E6B-BFA8-6000558AB449}" type="slidenum">
+              <a:rPr lang="zh-CN" altLang="en-US" smtClean="0"/>
+              <a:t>‹#›</a:t>
+            </a:fld>
+            <a:endParaRPr lang="zh-CN" altLang="en-US"/>
+          </a:p>
+        </p:txBody>
+      </p:sp>
+    </p:spTree>
+    <p:extLst>
+      <p:ext uri="{BB962C8B-B14F-4D97-AF65-F5344CB8AC3E}">
+        <p14:creationId xmlns:p14="http://schemas.microsoft.com/office/powerpoint/2010/main" val="3223489384"/>
+      </p:ext>
+    </p:extLst>
+  </p:cSld>
+  <p:clrMap bg1="lt1" tx1="dk1" bg2="lt2" tx2="dk2" accent1="accent1" accent2="accent2" accent3="accent3" accent4="accent4" accent5="accent5" accent6="accent6" hlink="hlink" folHlink="folHlink"/>
+  <p:notesStyle>
+    <a:lvl1pPr marL="0" algn="l" defTabSz="383230" rtl="0" eaLnBrk="1" latinLnBrk="0" hangingPunct="1">
+      <a:defRPr sz="503" kern="1200">
+        <a:solidFill>
+          <a:schemeClr val="tx1"/>
+        </a:solidFill>
+        <a:latin typeface="+mn-lt"/>
+        <a:ea typeface="+mn-ea"/>
+        <a:cs typeface="+mn-cs"/>
+      </a:defRPr>
+    </a:lvl1pPr>
+    <a:lvl2pPr marL="191614" algn="l" defTabSz="383230" rtl="0" eaLnBrk="1" latinLnBrk="0" hangingPunct="1">
+      <a:defRPr sz="503" kern="1200">
+        <a:solidFill>
+          <a:schemeClr val="tx1"/>
+        </a:solidFill>
+        <a:latin typeface="+mn-lt"/>
+        <a:ea typeface="+mn-ea"/>
+        <a:cs typeface="+mn-cs"/>
+      </a:defRPr>
+    </a:lvl2pPr>
+    <a:lvl3pPr marL="383230" algn="l" defTabSz="383230" rtl="0" eaLnBrk="1" latinLnBrk="0" hangingPunct="1">
+      <a:defRPr sz="503" kern="1200">
+        <a:solidFill>
+          <a:schemeClr val="tx1"/>
+        </a:solidFill>
+        <a:latin typeface="+mn-lt"/>
+        <a:ea typeface="+mn-ea"/>
+        <a:cs typeface="+mn-cs"/>
+      </a:defRPr>
+    </a:lvl3pPr>
+    <a:lvl4pPr marL="574844" algn="l" defTabSz="383230" rtl="0" eaLnBrk="1" latinLnBrk="0" hangingPunct="1">
+      <a:defRPr sz="503" kern="1200">
+        <a:solidFill>
+          <a:schemeClr val="tx1"/>
+        </a:solidFill>
+        <a:latin typeface="+mn-lt"/>
+        <a:ea typeface="+mn-ea"/>
+        <a:cs typeface="+mn-cs"/>
+      </a:defRPr>
+    </a:lvl4pPr>
+    <a:lvl5pPr marL="766461" algn="l" defTabSz="383230" rtl="0" eaLnBrk="1" latinLnBrk="0" hangingPunct="1">
+      <a:defRPr sz="503" kern="1200">
+        <a:solidFill>
+          <a:schemeClr val="tx1"/>
+        </a:solidFill>
+        <a:latin typeface="+mn-lt"/>
+        <a:ea typeface="+mn-ea"/>
+        <a:cs typeface="+mn-cs"/>
+      </a:defRPr>
+    </a:lvl5pPr>
+    <a:lvl6pPr marL="958075" algn="l" defTabSz="383230" rtl="0" eaLnBrk="1" latinLnBrk="0" hangingPunct="1">
+      <a:defRPr sz="503" kern="1200">
+        <a:solidFill>
+          <a:schemeClr val="tx1"/>
+        </a:solidFill>
+        <a:latin typeface="+mn-lt"/>
+        <a:ea typeface="+mn-ea"/>
+        <a:cs typeface="+mn-cs"/>
+      </a:defRPr>
+    </a:lvl6pPr>
+    <a:lvl7pPr marL="1149691" algn="l" defTabSz="383230" rtl="0" eaLnBrk="1" latinLnBrk="0" hangingPunct="1">
+      <a:defRPr sz="503" kern="1200">
+        <a:solidFill>
+          <a:schemeClr val="tx1"/>
+        </a:solidFill>
+        <a:latin typeface="+mn-lt"/>
+        <a:ea typeface="+mn-ea"/>
+        <a:cs typeface="+mn-cs"/>
+      </a:defRPr>
+    </a:lvl7pPr>
+    <a:lvl8pPr marL="1341305" algn="l" defTabSz="383230" rtl="0" eaLnBrk="1" latinLnBrk="0" hangingPunct="1">
+      <a:defRPr sz="503" kern="1200">
+        <a:solidFill>
+          <a:schemeClr val="tx1"/>
+        </a:solidFill>
+        <a:latin typeface="+mn-lt"/>
+        <a:ea typeface="+mn-ea"/>
+        <a:cs typeface="+mn-cs"/>
+      </a:defRPr>
+    </a:lvl8pPr>
+    <a:lvl9pPr marL="1532921" algn="l" defTabSz="383230" rtl="0" eaLnBrk="1" latinLnBrk="0" hangingPunct="1">
+      <a:defRPr sz="503" kern="1200">
+        <a:solidFill>
+          <a:schemeClr val="tx1"/>
+        </a:solidFill>
+        <a:latin typeface="+mn-lt"/>
+        <a:ea typeface="+mn-ea"/>
+        <a:cs typeface="+mn-cs"/>
+      </a:defRPr>
+    </a:lvl9pPr>
+  </p:notesStyle>
+</p:notesMaster>
+</file>
+
+<file path=ppt/notesSlides/notesSlide1.xml><?xml version="1.0" encoding="utf-8"?>
+<p:notes xmlns:a="http://schemas.openxmlformats.org/drawingml/2006/main" xmlns:r="http://schemas.openxmlformats.org/officeDocument/2006/relationships" xmlns:p="http://schemas.openxmlformats.org/presentationml/2006/main">
+  <p:cSld>
+    <p:spTree>
+      <p:nvGrpSpPr>
+        <p:cNvPr id="1" name=""/>
+        <p:cNvGrpSpPr/>
+        <p:nvPr/>
+      </p:nvGrpSpPr>
+      <p:grpSpPr>
+        <a:xfrm>
+          <a:off x="0" y="0"/>
+          <a:ext cx="0" cy="0"/>
+          <a:chOff x="0" y="0"/>
+          <a:chExt cx="0" cy="0"/>
+        </a:xfrm>
+      </p:grpSpPr>
+      <p:sp>
+        <p:nvSpPr>
+          <p:cNvPr id="2" name="幻灯片图像占位符 1"/>
+          <p:cNvSpPr>
+            <a:spLocks noGrp="1" noRot="1" noChangeAspect="1"/>
+          </p:cNvSpPr>
+          <p:nvPr>
+            <p:ph type="sldImg"/>
+          </p:nvPr>
+        </p:nvSpPr>
+        <p:spPr/>
+      </p:sp>
+      <p:sp>
+        <p:nvSpPr>
+          <p:cNvPr id="3" name="备注占位符 2"/>
+          <p:cNvSpPr>
+            <a:spLocks noGrp="1"/>
+          </p:cNvSpPr>
+          <p:nvPr>
+            <p:ph type="body" idx="1"/>
+          </p:nvPr>
+        </p:nvSpPr>
+        <p:spPr/>
+        <p:txBody>
+          <a:bodyPr/>
+          <a:lstStyle/>
+          <a:p>
+            <a:pPr algn="ctr"/>
+            <a:r>
+              <a:rPr lang="zh-CN" altLang="en-US" sz="800" dirty="0" smtClean="0"/>
+              <a:t>（在使用“画图”打开</a:t>
+            </a:r>
+            <a:r>
+              <a:rPr lang="en-US" altLang="zh-CN" sz="800" dirty="0" smtClean="0"/>
+              <a:t>banner110.jpg</a:t>
+            </a:r>
+            <a:r>
+              <a:rPr lang="zh-CN" altLang="en-US" sz="800" dirty="0" smtClean="0"/>
+              <a:t>文件，剪切和调整长宽）</a:t>
+            </a:r>
+            <a:r>
+              <a:rPr lang="en-US" altLang="zh-CN" sz="800" dirty="0" smtClean="0">
+                <a:solidFill>
+                  <a:srgbClr val="FF0000"/>
+                </a:solidFill>
+              </a:rPr>
+              <a:t>1000*200 </a:t>
+            </a:r>
+            <a:r>
+              <a:rPr lang="zh-CN" altLang="en-US" sz="800" dirty="0" smtClean="0">
+                <a:solidFill>
+                  <a:srgbClr val="FF0000"/>
+                </a:solidFill>
+              </a:rPr>
+              <a:t>像素 </a:t>
+            </a:r>
+            <a:r>
+              <a:rPr lang="zh-CN" altLang="en-US" sz="800" dirty="0" smtClean="0"/>
+              <a:t>→ 适合个人网站的</a:t>
+            </a:r>
+            <a:r>
+              <a:rPr lang="en-US" altLang="zh-CN" sz="800" dirty="0" smtClean="0"/>
+              <a:t>banner</a:t>
+            </a:r>
+            <a:endParaRPr lang="zh-CN" altLang="en-US" sz="800" dirty="0" smtClean="0"/>
+          </a:p>
+        </p:txBody>
+      </p:sp>
+      <p:sp>
+        <p:nvSpPr>
+          <p:cNvPr id="4" name="灯片编号占位符 3"/>
+          <p:cNvSpPr>
+            <a:spLocks noGrp="1"/>
+          </p:cNvSpPr>
+          <p:nvPr>
+            <p:ph type="sldNum" sz="quarter" idx="10"/>
+          </p:nvPr>
+        </p:nvSpPr>
+        <p:spPr/>
+        <p:txBody>
+          <a:bodyPr/>
+          <a:lstStyle/>
+          <a:p>
+            <a:fld id="{700D12A1-17D8-4E6B-BFA8-6000558AB449}" type="slidenum">
+              <a:rPr lang="zh-CN" altLang="en-US" smtClean="0"/>
+              <a:t>1</a:t>
+            </a:fld>
+            <a:endParaRPr lang="zh-CN" altLang="en-US"/>
+          </a:p>
+        </p:txBody>
+      </p:sp>
+    </p:spTree>
+    <p:extLst>
+      <p:ext uri="{BB962C8B-B14F-4D97-AF65-F5344CB8AC3E}">
+        <p14:creationId xmlns:p14="http://schemas.microsoft.com/office/powerpoint/2010/main" val="1117967857"/>
+      </p:ext>
+    </p:extLst>
+  </p:cSld>
+  <p:clrMapOvr>
+    <a:masterClrMapping/>
+  </p:clrMapOvr>
+</p:notes>
 </file>
 
 <file path=ppt/slideLayouts/slideLayout1.xml><?xml version="1.0" encoding="utf-8"?>
@@ -126,13 +605,7 @@
       </p:grpSpPr>
       <p:sp>
         <p:nvSpPr>
-          <p:cNvPr id="2" name="标题 1">
-            <a:extLst>
-              <a:ext uri="{FF2B5EF4-FFF2-40B4-BE49-F238E27FC236}">
-                <a16:creationId xmlns:a16="http://schemas.microsoft.com/office/drawing/2014/main" id="{AEBF1F77-E8B8-4877-BC4F-78D193168CCF}"/>
-              </a:ext>
-            </a:extLst>
-          </p:cNvPr>
+          <p:cNvPr id="2" name="Title 1"/>
           <p:cNvSpPr>
             <a:spLocks noGrp="1"/>
           </p:cNvSpPr>
@@ -142,34 +615,29 @@
         </p:nvSpPr>
         <p:spPr>
           <a:xfrm>
-            <a:off x="1524000" y="1122363"/>
-            <a:ext cx="9144000" cy="2387600"/>
+            <a:off x="940594" y="474146"/>
+            <a:ext cx="5643563" cy="1008651"/>
           </a:xfrm>
         </p:spPr>
         <p:txBody>
           <a:bodyPr anchor="b"/>
           <a:lstStyle>
             <a:lvl1pPr algn="ctr">
-              <a:defRPr sz="6000"/>
+              <a:defRPr sz="2535"/>
             </a:lvl1pPr>
           </a:lstStyle>
           <a:p>
             <a:r>
-              <a:rPr lang="zh-CN" altLang="en-US"/>
+              <a:rPr lang="zh-CN" altLang="en-US" smtClean="0"/>
               <a:t>单击此处编辑母版标题样式</a:t>
             </a:r>
-          </a:p>
-        </p:txBody>
-      </p:sp>
-      <p:sp>
-        <p:nvSpPr>
-          <p:cNvPr id="3" name="副标题 2">
-            <a:extLst>
-              <a:ext uri="{FF2B5EF4-FFF2-40B4-BE49-F238E27FC236}">
-                <a16:creationId xmlns:a16="http://schemas.microsoft.com/office/drawing/2014/main" id="{2CB101C2-7C93-4333-8755-DA334DEAD693}"/>
-              </a:ext>
-            </a:extLst>
-          </p:cNvPr>
+            <a:endParaRPr lang="en-US" dirty="0"/>
+          </a:p>
+        </p:txBody>
+      </p:sp>
+      <p:sp>
+        <p:nvSpPr>
+          <p:cNvPr id="3" name="Subtitle 2"/>
           <p:cNvSpPr>
             <a:spLocks noGrp="1"/>
           </p:cNvSpPr>
@@ -179,8 +647,8 @@
         </p:nvSpPr>
         <p:spPr>
           <a:xfrm>
-            <a:off x="1524000" y="3602038"/>
-            <a:ext cx="9144000" cy="1655762"/>
+            <a:off x="940594" y="1521695"/>
+            <a:ext cx="5643563" cy="699483"/>
           </a:xfrm>
         </p:spPr>
         <p:txBody>
@@ -188,58 +656,53 @@
           <a:lstStyle>
             <a:lvl1pPr marL="0" indent="0" algn="ctr">
               <a:buNone/>
-              <a:defRPr sz="2400"/>
+              <a:defRPr sz="1014"/>
             </a:lvl1pPr>
-            <a:lvl2pPr marL="457200" indent="0" algn="ctr">
-              <a:buNone/>
-              <a:defRPr sz="2000"/>
+            <a:lvl2pPr marL="193167" indent="0" algn="ctr">
+              <a:buNone/>
+              <a:defRPr sz="845"/>
             </a:lvl2pPr>
-            <a:lvl3pPr marL="914400" indent="0" algn="ctr">
-              <a:buNone/>
-              <a:defRPr sz="1800"/>
+            <a:lvl3pPr marL="386334" indent="0" algn="ctr">
+              <a:buNone/>
+              <a:defRPr sz="761"/>
             </a:lvl3pPr>
-            <a:lvl4pPr marL="1371600" indent="0" algn="ctr">
-              <a:buNone/>
-              <a:defRPr sz="1600"/>
+            <a:lvl4pPr marL="579501" indent="0" algn="ctr">
+              <a:buNone/>
+              <a:defRPr sz="676"/>
             </a:lvl4pPr>
-            <a:lvl5pPr marL="1828800" indent="0" algn="ctr">
-              <a:buNone/>
-              <a:defRPr sz="1600"/>
+            <a:lvl5pPr marL="772668" indent="0" algn="ctr">
+              <a:buNone/>
+              <a:defRPr sz="676"/>
             </a:lvl5pPr>
-            <a:lvl6pPr marL="2286000" indent="0" algn="ctr">
-              <a:buNone/>
-              <a:defRPr sz="1600"/>
+            <a:lvl6pPr marL="965835" indent="0" algn="ctr">
+              <a:buNone/>
+              <a:defRPr sz="676"/>
             </a:lvl6pPr>
-            <a:lvl7pPr marL="2743200" indent="0" algn="ctr">
-              <a:buNone/>
-              <a:defRPr sz="1600"/>
+            <a:lvl7pPr marL="1159002" indent="0" algn="ctr">
+              <a:buNone/>
+              <a:defRPr sz="676"/>
             </a:lvl7pPr>
-            <a:lvl8pPr marL="3200400" indent="0" algn="ctr">
-              <a:buNone/>
-              <a:defRPr sz="1600"/>
+            <a:lvl8pPr marL="1352169" indent="0" algn="ctr">
+              <a:buNone/>
+              <a:defRPr sz="676"/>
             </a:lvl8pPr>
-            <a:lvl9pPr marL="3657600" indent="0" algn="ctr">
-              <a:buNone/>
-              <a:defRPr sz="1600"/>
+            <a:lvl9pPr marL="1545336" indent="0" algn="ctr">
+              <a:buNone/>
+              <a:defRPr sz="676"/>
             </a:lvl9pPr>
           </a:lstStyle>
           <a:p>
             <a:r>
-              <a:rPr lang="zh-CN" altLang="en-US"/>
-              <a:t>单击此处编辑母版副标题样式</a:t>
-            </a:r>
-          </a:p>
-        </p:txBody>
-      </p:sp>
-      <p:sp>
-        <p:nvSpPr>
-          <p:cNvPr id="4" name="日期占位符 3">
-            <a:extLst>
-              <a:ext uri="{FF2B5EF4-FFF2-40B4-BE49-F238E27FC236}">
-                <a16:creationId xmlns:a16="http://schemas.microsoft.com/office/drawing/2014/main" id="{8491821D-9F4F-4A50-9F8B-2C8E2C99257F}"/>
-              </a:ext>
-            </a:extLst>
-          </p:cNvPr>
+              <a:rPr lang="zh-CN" altLang="en-US" smtClean="0"/>
+              <a:t>单击以编辑母版副标题样式</a:t>
+            </a:r>
+            <a:endParaRPr lang="en-US" dirty="0"/>
+          </a:p>
+        </p:txBody>
+      </p:sp>
+      <p:sp>
+        <p:nvSpPr>
+          <p:cNvPr id="4" name="Date Placeholder 3"/>
           <p:cNvSpPr>
             <a:spLocks noGrp="1"/>
           </p:cNvSpPr>
@@ -254,7 +717,7 @@
           <a:p>
             <a:fld id="{86716E46-D677-4FA8-974A-5B989B436838}" type="datetimeFigureOut">
               <a:rPr lang="zh-CN" altLang="en-US" smtClean="0"/>
-              <a:t>2018/8/17</a:t>
+              <a:t>2021/04/02</a:t>
             </a:fld>
             <a:endParaRPr lang="zh-CN" altLang="en-US"/>
           </a:p>
@@ -262,13 +725,7 @@
       </p:sp>
       <p:sp>
         <p:nvSpPr>
-          <p:cNvPr id="5" name="页脚占位符 4">
-            <a:extLst>
-              <a:ext uri="{FF2B5EF4-FFF2-40B4-BE49-F238E27FC236}">
-                <a16:creationId xmlns:a16="http://schemas.microsoft.com/office/drawing/2014/main" id="{FDA0B121-8976-4552-88C0-B63AC8F3C30B}"/>
-              </a:ext>
-            </a:extLst>
-          </p:cNvPr>
+          <p:cNvPr id="5" name="Footer Placeholder 4"/>
           <p:cNvSpPr>
             <a:spLocks noGrp="1"/>
           </p:cNvSpPr>
@@ -287,13 +744,7 @@
       </p:sp>
       <p:sp>
         <p:nvSpPr>
-          <p:cNvPr id="6" name="灯片编号占位符 5">
-            <a:extLst>
-              <a:ext uri="{FF2B5EF4-FFF2-40B4-BE49-F238E27FC236}">
-                <a16:creationId xmlns:a16="http://schemas.microsoft.com/office/drawing/2014/main" id="{4CD725FF-27E1-4EE4-B06E-9BE4A4BD31B6}"/>
-              </a:ext>
-            </a:extLst>
-          </p:cNvPr>
+          <p:cNvPr id="6" name="Slide Number Placeholder 5"/>
           <p:cNvSpPr>
             <a:spLocks noGrp="1"/>
           </p:cNvSpPr>
@@ -317,7 +768,7 @@
     </p:spTree>
     <p:extLst>
       <p:ext uri="{BB962C8B-B14F-4D97-AF65-F5344CB8AC3E}">
-        <p14:creationId xmlns:p14="http://schemas.microsoft.com/office/powerpoint/2010/main" val="2568749246"/>
+        <p14:creationId xmlns:p14="http://schemas.microsoft.com/office/powerpoint/2010/main" val="4038906704"/>
       </p:ext>
     </p:extLst>
   </p:cSld>
@@ -346,13 +797,7 @@
       </p:grpSpPr>
       <p:sp>
         <p:nvSpPr>
-          <p:cNvPr id="2" name="标题 1">
-            <a:extLst>
-              <a:ext uri="{FF2B5EF4-FFF2-40B4-BE49-F238E27FC236}">
-                <a16:creationId xmlns:a16="http://schemas.microsoft.com/office/drawing/2014/main" id="{2CFC6BF4-0E91-406F-BA07-77ADD5C729EF}"/>
-              </a:ext>
-            </a:extLst>
-          </p:cNvPr>
+          <p:cNvPr id="2" name="Title 1"/>
           <p:cNvSpPr>
             <a:spLocks noGrp="1"/>
           </p:cNvSpPr>
@@ -366,21 +811,16 @@
           <a:lstStyle/>
           <a:p>
             <a:r>
-              <a:rPr lang="zh-CN" altLang="en-US"/>
+              <a:rPr lang="zh-CN" altLang="en-US" smtClean="0"/>
               <a:t>单击此处编辑母版标题样式</a:t>
             </a:r>
-          </a:p>
-        </p:txBody>
-      </p:sp>
-      <p:sp>
-        <p:nvSpPr>
-          <p:cNvPr id="3" name="竖排文字占位符 2">
-            <a:extLst>
-              <a:ext uri="{FF2B5EF4-FFF2-40B4-BE49-F238E27FC236}">
-                <a16:creationId xmlns:a16="http://schemas.microsoft.com/office/drawing/2014/main" id="{958A46BE-9142-4FD0-B892-3745B2DA831C}"/>
-              </a:ext>
-            </a:extLst>
-          </p:cNvPr>
+            <a:endParaRPr lang="en-US" dirty="0"/>
+          </a:p>
+        </p:txBody>
+      </p:sp>
+      <p:sp>
+        <p:nvSpPr>
+          <p:cNvPr id="3" name="Vertical Text Placeholder 2"/>
           <p:cNvSpPr>
             <a:spLocks noGrp="1"/>
           </p:cNvSpPr>
@@ -395,49 +835,44 @@
           <a:p>
             <a:pPr lvl="0"/>
             <a:r>
-              <a:rPr lang="zh-CN" altLang="en-US"/>
+              <a:rPr lang="zh-CN" altLang="en-US" smtClean="0"/>
               <a:t>编辑母版文本样式</a:t>
             </a:r>
           </a:p>
           <a:p>
             <a:pPr lvl="1"/>
             <a:r>
-              <a:rPr lang="zh-CN" altLang="en-US"/>
+              <a:rPr lang="zh-CN" altLang="en-US" smtClean="0"/>
               <a:t>第二级</a:t>
             </a:r>
           </a:p>
           <a:p>
             <a:pPr lvl="2"/>
             <a:r>
-              <a:rPr lang="zh-CN" altLang="en-US"/>
+              <a:rPr lang="zh-CN" altLang="en-US" smtClean="0"/>
               <a:t>第三级</a:t>
             </a:r>
           </a:p>
           <a:p>
             <a:pPr lvl="3"/>
             <a:r>
-              <a:rPr lang="zh-CN" altLang="en-US"/>
+              <a:rPr lang="zh-CN" altLang="en-US" smtClean="0"/>
               <a:t>第四级</a:t>
             </a:r>
           </a:p>
           <a:p>
             <a:pPr lvl="4"/>
             <a:r>
-              <a:rPr lang="zh-CN" altLang="en-US"/>
+              <a:rPr lang="zh-CN" altLang="en-US" smtClean="0"/>
               <a:t>第五级</a:t>
             </a:r>
-          </a:p>
-        </p:txBody>
-      </p:sp>
-      <p:sp>
-        <p:nvSpPr>
-          <p:cNvPr id="4" name="日期占位符 3">
-            <a:extLst>
-              <a:ext uri="{FF2B5EF4-FFF2-40B4-BE49-F238E27FC236}">
-                <a16:creationId xmlns:a16="http://schemas.microsoft.com/office/drawing/2014/main" id="{D47DF586-4BF1-4153-9F46-19E9BA80B5AA}"/>
-              </a:ext>
-            </a:extLst>
-          </p:cNvPr>
+            <a:endParaRPr lang="en-US" dirty="0"/>
+          </a:p>
+        </p:txBody>
+      </p:sp>
+      <p:sp>
+        <p:nvSpPr>
+          <p:cNvPr id="4" name="Date Placeholder 3"/>
           <p:cNvSpPr>
             <a:spLocks noGrp="1"/>
           </p:cNvSpPr>
@@ -452,7 +887,7 @@
           <a:p>
             <a:fld id="{86716E46-D677-4FA8-974A-5B989B436838}" type="datetimeFigureOut">
               <a:rPr lang="zh-CN" altLang="en-US" smtClean="0"/>
-              <a:t>2018/8/17</a:t>
+              <a:t>2021/04/02</a:t>
             </a:fld>
             <a:endParaRPr lang="zh-CN" altLang="en-US"/>
           </a:p>
@@ -460,13 +895,7 @@
       </p:sp>
       <p:sp>
         <p:nvSpPr>
-          <p:cNvPr id="5" name="页脚占位符 4">
-            <a:extLst>
-              <a:ext uri="{FF2B5EF4-FFF2-40B4-BE49-F238E27FC236}">
-                <a16:creationId xmlns:a16="http://schemas.microsoft.com/office/drawing/2014/main" id="{57B104AA-EC5E-4B48-9F74-48C8E36B0B2B}"/>
-              </a:ext>
-            </a:extLst>
-          </p:cNvPr>
+          <p:cNvPr id="5" name="Footer Placeholder 4"/>
           <p:cNvSpPr>
             <a:spLocks noGrp="1"/>
           </p:cNvSpPr>
@@ -485,13 +914,7 @@
       </p:sp>
       <p:sp>
         <p:nvSpPr>
-          <p:cNvPr id="6" name="灯片编号占位符 5">
-            <a:extLst>
-              <a:ext uri="{FF2B5EF4-FFF2-40B4-BE49-F238E27FC236}">
-                <a16:creationId xmlns:a16="http://schemas.microsoft.com/office/drawing/2014/main" id="{8152E055-6850-4150-B7A3-C82AF44126BB}"/>
-              </a:ext>
-            </a:extLst>
-          </p:cNvPr>
+          <p:cNvPr id="6" name="Slide Number Placeholder 5"/>
           <p:cNvSpPr>
             <a:spLocks noGrp="1"/>
           </p:cNvSpPr>
@@ -515,7 +938,7 @@
     </p:spTree>
     <p:extLst>
       <p:ext uri="{BB962C8B-B14F-4D97-AF65-F5344CB8AC3E}">
-        <p14:creationId xmlns:p14="http://schemas.microsoft.com/office/powerpoint/2010/main" val="1528193734"/>
+        <p14:creationId xmlns:p14="http://schemas.microsoft.com/office/powerpoint/2010/main" val="3172615305"/>
       </p:ext>
     </p:extLst>
   </p:cSld>
@@ -544,13 +967,7 @@
       </p:grpSpPr>
       <p:sp>
         <p:nvSpPr>
-          <p:cNvPr id="2" name="竖排标题 1">
-            <a:extLst>
-              <a:ext uri="{FF2B5EF4-FFF2-40B4-BE49-F238E27FC236}">
-                <a16:creationId xmlns:a16="http://schemas.microsoft.com/office/drawing/2014/main" id="{7E72B66F-E9ED-4C2B-AB63-D75090F34676}"/>
-              </a:ext>
-            </a:extLst>
-          </p:cNvPr>
+          <p:cNvPr id="2" name="Vertical Title 1"/>
           <p:cNvSpPr>
             <a:spLocks noGrp="1"/>
           </p:cNvSpPr>
@@ -560,8 +977,8 @@
         </p:nvSpPr>
         <p:spPr>
           <a:xfrm>
-            <a:off x="8724900" y="365125"/>
-            <a:ext cx="2628900" cy="5811838"/>
+            <a:off x="5384899" y="154248"/>
+            <a:ext cx="1622524" cy="2455233"/>
           </a:xfrm>
         </p:spPr>
         <p:txBody>
@@ -569,21 +986,16 @@
           <a:lstStyle/>
           <a:p>
             <a:r>
-              <a:rPr lang="zh-CN" altLang="en-US"/>
+              <a:rPr lang="zh-CN" altLang="en-US" smtClean="0"/>
               <a:t>单击此处编辑母版标题样式</a:t>
             </a:r>
-          </a:p>
-        </p:txBody>
-      </p:sp>
-      <p:sp>
-        <p:nvSpPr>
-          <p:cNvPr id="3" name="竖排文字占位符 2">
-            <a:extLst>
-              <a:ext uri="{FF2B5EF4-FFF2-40B4-BE49-F238E27FC236}">
-                <a16:creationId xmlns:a16="http://schemas.microsoft.com/office/drawing/2014/main" id="{0990ECE6-735F-46FC-B952-3F210869B0E3}"/>
-              </a:ext>
-            </a:extLst>
-          </p:cNvPr>
+            <a:endParaRPr lang="en-US" dirty="0"/>
+          </a:p>
+        </p:txBody>
+      </p:sp>
+      <p:sp>
+        <p:nvSpPr>
+          <p:cNvPr id="3" name="Vertical Text Placeholder 2"/>
           <p:cNvSpPr>
             <a:spLocks noGrp="1"/>
           </p:cNvSpPr>
@@ -593,8 +1005,8 @@
         </p:nvSpPr>
         <p:spPr>
           <a:xfrm>
-            <a:off x="838200" y="365125"/>
-            <a:ext cx="7734300" cy="5811838"/>
+            <a:off x="517327" y="154248"/>
+            <a:ext cx="4773513" cy="2455233"/>
           </a:xfrm>
         </p:spPr>
         <p:txBody>
@@ -603,49 +1015,44 @@
           <a:p>
             <a:pPr lvl="0"/>
             <a:r>
-              <a:rPr lang="zh-CN" altLang="en-US"/>
+              <a:rPr lang="zh-CN" altLang="en-US" smtClean="0"/>
               <a:t>编辑母版文本样式</a:t>
             </a:r>
           </a:p>
           <a:p>
             <a:pPr lvl="1"/>
             <a:r>
-              <a:rPr lang="zh-CN" altLang="en-US"/>
+              <a:rPr lang="zh-CN" altLang="en-US" smtClean="0"/>
               <a:t>第二级</a:t>
             </a:r>
           </a:p>
           <a:p>
             <a:pPr lvl="2"/>
             <a:r>
-              <a:rPr lang="zh-CN" altLang="en-US"/>
+              <a:rPr lang="zh-CN" altLang="en-US" smtClean="0"/>
               <a:t>第三级</a:t>
             </a:r>
           </a:p>
           <a:p>
             <a:pPr lvl="3"/>
             <a:r>
-              <a:rPr lang="zh-CN" altLang="en-US"/>
+              <a:rPr lang="zh-CN" altLang="en-US" smtClean="0"/>
               <a:t>第四级</a:t>
             </a:r>
           </a:p>
           <a:p>
             <a:pPr lvl="4"/>
             <a:r>
-              <a:rPr lang="zh-CN" altLang="en-US"/>
+              <a:rPr lang="zh-CN" altLang="en-US" smtClean="0"/>
               <a:t>第五级</a:t>
             </a:r>
-          </a:p>
-        </p:txBody>
-      </p:sp>
-      <p:sp>
-        <p:nvSpPr>
-          <p:cNvPr id="4" name="日期占位符 3">
-            <a:extLst>
-              <a:ext uri="{FF2B5EF4-FFF2-40B4-BE49-F238E27FC236}">
-                <a16:creationId xmlns:a16="http://schemas.microsoft.com/office/drawing/2014/main" id="{739356C7-74B8-4C10-AB6A-B26437A0A47E}"/>
-              </a:ext>
-            </a:extLst>
-          </p:cNvPr>
+            <a:endParaRPr lang="en-US" dirty="0"/>
+          </a:p>
+        </p:txBody>
+      </p:sp>
+      <p:sp>
+        <p:nvSpPr>
+          <p:cNvPr id="4" name="Date Placeholder 3"/>
           <p:cNvSpPr>
             <a:spLocks noGrp="1"/>
           </p:cNvSpPr>
@@ -660,7 +1067,7 @@
           <a:p>
             <a:fld id="{86716E46-D677-4FA8-974A-5B989B436838}" type="datetimeFigureOut">
               <a:rPr lang="zh-CN" altLang="en-US" smtClean="0"/>
-              <a:t>2018/8/17</a:t>
+              <a:t>2021/04/02</a:t>
             </a:fld>
             <a:endParaRPr lang="zh-CN" altLang="en-US"/>
           </a:p>
@@ -668,13 +1075,7 @@
       </p:sp>
       <p:sp>
         <p:nvSpPr>
-          <p:cNvPr id="5" name="页脚占位符 4">
-            <a:extLst>
-              <a:ext uri="{FF2B5EF4-FFF2-40B4-BE49-F238E27FC236}">
-                <a16:creationId xmlns:a16="http://schemas.microsoft.com/office/drawing/2014/main" id="{21A75E6A-963E-46A7-9DB2-DE967C4BBAD8}"/>
-              </a:ext>
-            </a:extLst>
-          </p:cNvPr>
+          <p:cNvPr id="5" name="Footer Placeholder 4"/>
           <p:cNvSpPr>
             <a:spLocks noGrp="1"/>
           </p:cNvSpPr>
@@ -693,13 +1094,7 @@
       </p:sp>
       <p:sp>
         <p:nvSpPr>
-          <p:cNvPr id="6" name="灯片编号占位符 5">
-            <a:extLst>
-              <a:ext uri="{FF2B5EF4-FFF2-40B4-BE49-F238E27FC236}">
-                <a16:creationId xmlns:a16="http://schemas.microsoft.com/office/drawing/2014/main" id="{4DC58EF1-B2D6-4EE7-8489-B97CED0A991C}"/>
-              </a:ext>
-            </a:extLst>
-          </p:cNvPr>
+          <p:cNvPr id="6" name="Slide Number Placeholder 5"/>
           <p:cNvSpPr>
             <a:spLocks noGrp="1"/>
           </p:cNvSpPr>
@@ -723,7 +1118,7 @@
     </p:spTree>
     <p:extLst>
       <p:ext uri="{BB962C8B-B14F-4D97-AF65-F5344CB8AC3E}">
-        <p14:creationId xmlns:p14="http://schemas.microsoft.com/office/powerpoint/2010/main" val="3543909088"/>
+        <p14:creationId xmlns:p14="http://schemas.microsoft.com/office/powerpoint/2010/main" val="4202337496"/>
       </p:ext>
     </p:extLst>
   </p:cSld>
@@ -752,13 +1147,7 @@
       </p:grpSpPr>
       <p:sp>
         <p:nvSpPr>
-          <p:cNvPr id="2" name="标题 1">
-            <a:extLst>
-              <a:ext uri="{FF2B5EF4-FFF2-40B4-BE49-F238E27FC236}">
-                <a16:creationId xmlns:a16="http://schemas.microsoft.com/office/drawing/2014/main" id="{E520E444-638E-4E8B-BCF1-759D652A4437}"/>
-              </a:ext>
-            </a:extLst>
-          </p:cNvPr>
+          <p:cNvPr id="2" name="Title 1"/>
           <p:cNvSpPr>
             <a:spLocks noGrp="1"/>
           </p:cNvSpPr>
@@ -772,21 +1161,16 @@
           <a:lstStyle/>
           <a:p>
             <a:r>
-              <a:rPr lang="zh-CN" altLang="en-US"/>
+              <a:rPr lang="zh-CN" altLang="en-US" smtClean="0"/>
               <a:t>单击此处编辑母版标题样式</a:t>
             </a:r>
-          </a:p>
-        </p:txBody>
-      </p:sp>
-      <p:sp>
-        <p:nvSpPr>
-          <p:cNvPr id="3" name="内容占位符 2">
-            <a:extLst>
-              <a:ext uri="{FF2B5EF4-FFF2-40B4-BE49-F238E27FC236}">
-                <a16:creationId xmlns:a16="http://schemas.microsoft.com/office/drawing/2014/main" id="{04222C22-3FB1-4A76-8988-004B4E8939C7}"/>
-              </a:ext>
-            </a:extLst>
-          </p:cNvPr>
+            <a:endParaRPr lang="en-US" dirty="0"/>
+          </a:p>
+        </p:txBody>
+      </p:sp>
+      <p:sp>
+        <p:nvSpPr>
+          <p:cNvPr id="3" name="Content Placeholder 2"/>
           <p:cNvSpPr>
             <a:spLocks noGrp="1"/>
           </p:cNvSpPr>
@@ -801,49 +1185,44 @@
           <a:p>
             <a:pPr lvl="0"/>
             <a:r>
-              <a:rPr lang="zh-CN" altLang="en-US"/>
+              <a:rPr lang="zh-CN" altLang="en-US" smtClean="0"/>
               <a:t>编辑母版文本样式</a:t>
             </a:r>
           </a:p>
           <a:p>
             <a:pPr lvl="1"/>
             <a:r>
-              <a:rPr lang="zh-CN" altLang="en-US"/>
+              <a:rPr lang="zh-CN" altLang="en-US" smtClean="0"/>
               <a:t>第二级</a:t>
             </a:r>
           </a:p>
           <a:p>
             <a:pPr lvl="2"/>
             <a:r>
-              <a:rPr lang="zh-CN" altLang="en-US"/>
+              <a:rPr lang="zh-CN" altLang="en-US" smtClean="0"/>
               <a:t>第三级</a:t>
             </a:r>
           </a:p>
           <a:p>
             <a:pPr lvl="3"/>
             <a:r>
-              <a:rPr lang="zh-CN" altLang="en-US"/>
+              <a:rPr lang="zh-CN" altLang="en-US" smtClean="0"/>
               <a:t>第四级</a:t>
             </a:r>
           </a:p>
           <a:p>
             <a:pPr lvl="4"/>
             <a:r>
-              <a:rPr lang="zh-CN" altLang="en-US"/>
+              <a:rPr lang="zh-CN" altLang="en-US" smtClean="0"/>
               <a:t>第五级</a:t>
             </a:r>
-          </a:p>
-        </p:txBody>
-      </p:sp>
-      <p:sp>
-        <p:nvSpPr>
-          <p:cNvPr id="4" name="日期占位符 3">
-            <a:extLst>
-              <a:ext uri="{FF2B5EF4-FFF2-40B4-BE49-F238E27FC236}">
-                <a16:creationId xmlns:a16="http://schemas.microsoft.com/office/drawing/2014/main" id="{1E6B1CE2-9C29-476B-B8C1-1B724977F599}"/>
-              </a:ext>
-            </a:extLst>
-          </p:cNvPr>
+            <a:endParaRPr lang="en-US" dirty="0"/>
+          </a:p>
+        </p:txBody>
+      </p:sp>
+      <p:sp>
+        <p:nvSpPr>
+          <p:cNvPr id="4" name="Date Placeholder 3"/>
           <p:cNvSpPr>
             <a:spLocks noGrp="1"/>
           </p:cNvSpPr>
@@ -858,7 +1237,7 @@
           <a:p>
             <a:fld id="{86716E46-D677-4FA8-974A-5B989B436838}" type="datetimeFigureOut">
               <a:rPr lang="zh-CN" altLang="en-US" smtClean="0"/>
-              <a:t>2018/8/17</a:t>
+              <a:t>2021/04/02</a:t>
             </a:fld>
             <a:endParaRPr lang="zh-CN" altLang="en-US"/>
           </a:p>
@@ -866,13 +1245,7 @@
       </p:sp>
       <p:sp>
         <p:nvSpPr>
-          <p:cNvPr id="5" name="页脚占位符 4">
-            <a:extLst>
-              <a:ext uri="{FF2B5EF4-FFF2-40B4-BE49-F238E27FC236}">
-                <a16:creationId xmlns:a16="http://schemas.microsoft.com/office/drawing/2014/main" id="{C8853236-E3D8-4058-AD16-44A34C2D5799}"/>
-              </a:ext>
-            </a:extLst>
-          </p:cNvPr>
+          <p:cNvPr id="5" name="Footer Placeholder 4"/>
           <p:cNvSpPr>
             <a:spLocks noGrp="1"/>
           </p:cNvSpPr>
@@ -891,13 +1264,7 @@
       </p:sp>
       <p:sp>
         <p:nvSpPr>
-          <p:cNvPr id="6" name="灯片编号占位符 5">
-            <a:extLst>
-              <a:ext uri="{FF2B5EF4-FFF2-40B4-BE49-F238E27FC236}">
-                <a16:creationId xmlns:a16="http://schemas.microsoft.com/office/drawing/2014/main" id="{B9EA787F-27C8-4884-9AE4-DE8B4BE3FC18}"/>
-              </a:ext>
-            </a:extLst>
-          </p:cNvPr>
+          <p:cNvPr id="6" name="Slide Number Placeholder 5"/>
           <p:cNvSpPr>
             <a:spLocks noGrp="1"/>
           </p:cNvSpPr>
@@ -921,7 +1288,7 @@
     </p:spTree>
     <p:extLst>
       <p:ext uri="{BB962C8B-B14F-4D97-AF65-F5344CB8AC3E}">
-        <p14:creationId xmlns:p14="http://schemas.microsoft.com/office/powerpoint/2010/main" val="4058146254"/>
+        <p14:creationId xmlns:p14="http://schemas.microsoft.com/office/powerpoint/2010/main" val="3017054514"/>
       </p:ext>
     </p:extLst>
   </p:cSld>
@@ -950,13 +1317,7 @@
       </p:grpSpPr>
       <p:sp>
         <p:nvSpPr>
-          <p:cNvPr id="2" name="标题 1">
-            <a:extLst>
-              <a:ext uri="{FF2B5EF4-FFF2-40B4-BE49-F238E27FC236}">
-                <a16:creationId xmlns:a16="http://schemas.microsoft.com/office/drawing/2014/main" id="{0E1BA537-B425-47FC-9FBA-22FB1498F60C}"/>
-              </a:ext>
-            </a:extLst>
-          </p:cNvPr>
+          <p:cNvPr id="2" name="Title 1"/>
           <p:cNvSpPr>
             <a:spLocks noGrp="1"/>
           </p:cNvSpPr>
@@ -966,34 +1327,29 @@
         </p:nvSpPr>
         <p:spPr>
           <a:xfrm>
-            <a:off x="831850" y="1709738"/>
-            <a:ext cx="10515600" cy="2852737"/>
+            <a:off x="513407" y="722285"/>
+            <a:ext cx="6490097" cy="1205150"/>
           </a:xfrm>
         </p:spPr>
         <p:txBody>
           <a:bodyPr anchor="b"/>
           <a:lstStyle>
             <a:lvl1pPr>
-              <a:defRPr sz="6000"/>
+              <a:defRPr sz="2535"/>
             </a:lvl1pPr>
           </a:lstStyle>
           <a:p>
             <a:r>
-              <a:rPr lang="zh-CN" altLang="en-US"/>
+              <a:rPr lang="zh-CN" altLang="en-US" smtClean="0"/>
               <a:t>单击此处编辑母版标题样式</a:t>
             </a:r>
-          </a:p>
-        </p:txBody>
-      </p:sp>
-      <p:sp>
-        <p:nvSpPr>
-          <p:cNvPr id="3" name="文本占位符 2">
-            <a:extLst>
-              <a:ext uri="{FF2B5EF4-FFF2-40B4-BE49-F238E27FC236}">
-                <a16:creationId xmlns:a16="http://schemas.microsoft.com/office/drawing/2014/main" id="{ECE361F1-0552-4913-9736-AD514BD02097}"/>
-              </a:ext>
-            </a:extLst>
-          </p:cNvPr>
+            <a:endParaRPr lang="en-US" dirty="0"/>
+          </a:p>
+        </p:txBody>
+      </p:sp>
+      <p:sp>
+        <p:nvSpPr>
+          <p:cNvPr id="3" name="Text Placeholder 2"/>
           <p:cNvSpPr>
             <a:spLocks noGrp="1"/>
           </p:cNvSpPr>
@@ -1003,8 +1359,8 @@
         </p:nvSpPr>
         <p:spPr>
           <a:xfrm>
-            <a:off x="831850" y="4589463"/>
-            <a:ext cx="10515600" cy="1500187"/>
+            <a:off x="513407" y="1938836"/>
+            <a:ext cx="6490097" cy="633760"/>
           </a:xfrm>
         </p:spPr>
         <p:txBody>
@@ -1012,7 +1368,7 @@
           <a:lstStyle>
             <a:lvl1pPr marL="0" indent="0">
               <a:buNone/>
-              <a:defRPr sz="2400">
+              <a:defRPr sz="1014">
                 <a:solidFill>
                   <a:schemeClr val="tx1">
                     <a:tint val="75000"/>
@@ -1020,9 +1376,9 @@
                 </a:solidFill>
               </a:defRPr>
             </a:lvl1pPr>
-            <a:lvl2pPr marL="457200" indent="0">
-              <a:buNone/>
-              <a:defRPr sz="2000">
+            <a:lvl2pPr marL="193167" indent="0">
+              <a:buNone/>
+              <a:defRPr sz="845">
                 <a:solidFill>
                   <a:schemeClr val="tx1">
                     <a:tint val="75000"/>
@@ -1030,9 +1386,9 @@
                 </a:solidFill>
               </a:defRPr>
             </a:lvl2pPr>
-            <a:lvl3pPr marL="914400" indent="0">
-              <a:buNone/>
-              <a:defRPr sz="1800">
+            <a:lvl3pPr marL="386334" indent="0">
+              <a:buNone/>
+              <a:defRPr sz="761">
                 <a:solidFill>
                   <a:schemeClr val="tx1">
                     <a:tint val="75000"/>
@@ -1040,9 +1396,9 @@
                 </a:solidFill>
               </a:defRPr>
             </a:lvl3pPr>
-            <a:lvl4pPr marL="1371600" indent="0">
-              <a:buNone/>
-              <a:defRPr sz="1600">
+            <a:lvl4pPr marL="579501" indent="0">
+              <a:buNone/>
+              <a:defRPr sz="676">
                 <a:solidFill>
                   <a:schemeClr val="tx1">
                     <a:tint val="75000"/>
@@ -1050,9 +1406,9 @@
                 </a:solidFill>
               </a:defRPr>
             </a:lvl4pPr>
-            <a:lvl5pPr marL="1828800" indent="0">
-              <a:buNone/>
-              <a:defRPr sz="1600">
+            <a:lvl5pPr marL="772668" indent="0">
+              <a:buNone/>
+              <a:defRPr sz="676">
                 <a:solidFill>
                   <a:schemeClr val="tx1">
                     <a:tint val="75000"/>
@@ -1060,9 +1416,9 @@
                 </a:solidFill>
               </a:defRPr>
             </a:lvl5pPr>
-            <a:lvl6pPr marL="2286000" indent="0">
-              <a:buNone/>
-              <a:defRPr sz="1600">
+            <a:lvl6pPr marL="965835" indent="0">
+              <a:buNone/>
+              <a:defRPr sz="676">
                 <a:solidFill>
                   <a:schemeClr val="tx1">
                     <a:tint val="75000"/>
@@ -1070,9 +1426,9 @@
                 </a:solidFill>
               </a:defRPr>
             </a:lvl6pPr>
-            <a:lvl7pPr marL="2743200" indent="0">
-              <a:buNone/>
-              <a:defRPr sz="1600">
+            <a:lvl7pPr marL="1159002" indent="0">
+              <a:buNone/>
+              <a:defRPr sz="676">
                 <a:solidFill>
                   <a:schemeClr val="tx1">
                     <a:tint val="75000"/>
@@ -1080,9 +1436,9 @@
                 </a:solidFill>
               </a:defRPr>
             </a:lvl7pPr>
-            <a:lvl8pPr marL="3200400" indent="0">
-              <a:buNone/>
-              <a:defRPr sz="1600">
+            <a:lvl8pPr marL="1352169" indent="0">
+              <a:buNone/>
+              <a:defRPr sz="676">
                 <a:solidFill>
                   <a:schemeClr val="tx1">
                     <a:tint val="75000"/>
@@ -1090,9 +1446,9 @@
                 </a:solidFill>
               </a:defRPr>
             </a:lvl8pPr>
-            <a:lvl9pPr marL="3657600" indent="0">
-              <a:buNone/>
-              <a:defRPr sz="1600">
+            <a:lvl9pPr marL="1545336" indent="0">
+              <a:buNone/>
+              <a:defRPr sz="676">
                 <a:solidFill>
                   <a:schemeClr val="tx1">
                     <a:tint val="75000"/>
@@ -1104,7 +1460,7 @@
           <a:p>
             <a:pPr lvl="0"/>
             <a:r>
-              <a:rPr lang="zh-CN" altLang="en-US"/>
+              <a:rPr lang="zh-CN" altLang="en-US" smtClean="0"/>
               <a:t>编辑母版文本样式</a:t>
             </a:r>
           </a:p>
@@ -1112,13 +1468,7 @@
       </p:sp>
       <p:sp>
         <p:nvSpPr>
-          <p:cNvPr id="4" name="日期占位符 3">
-            <a:extLst>
-              <a:ext uri="{FF2B5EF4-FFF2-40B4-BE49-F238E27FC236}">
-                <a16:creationId xmlns:a16="http://schemas.microsoft.com/office/drawing/2014/main" id="{D38E380A-3317-4E5F-A511-3D9F46DDD23D}"/>
-              </a:ext>
-            </a:extLst>
-          </p:cNvPr>
+          <p:cNvPr id="4" name="Date Placeholder 3"/>
           <p:cNvSpPr>
             <a:spLocks noGrp="1"/>
           </p:cNvSpPr>
@@ -1133,7 +1483,7 @@
           <a:p>
             <a:fld id="{86716E46-D677-4FA8-974A-5B989B436838}" type="datetimeFigureOut">
               <a:rPr lang="zh-CN" altLang="en-US" smtClean="0"/>
-              <a:t>2018/8/17</a:t>
+              <a:t>2021/04/02</a:t>
             </a:fld>
             <a:endParaRPr lang="zh-CN" altLang="en-US"/>
           </a:p>
@@ -1141,13 +1491,7 @@
       </p:sp>
       <p:sp>
         <p:nvSpPr>
-          <p:cNvPr id="5" name="页脚占位符 4">
-            <a:extLst>
-              <a:ext uri="{FF2B5EF4-FFF2-40B4-BE49-F238E27FC236}">
-                <a16:creationId xmlns:a16="http://schemas.microsoft.com/office/drawing/2014/main" id="{412588CF-3069-4483-9E91-A56836F355EA}"/>
-              </a:ext>
-            </a:extLst>
-          </p:cNvPr>
+          <p:cNvPr id="5" name="Footer Placeholder 4"/>
           <p:cNvSpPr>
             <a:spLocks noGrp="1"/>
           </p:cNvSpPr>
@@ -1166,13 +1510,7 @@
       </p:sp>
       <p:sp>
         <p:nvSpPr>
-          <p:cNvPr id="6" name="灯片编号占位符 5">
-            <a:extLst>
-              <a:ext uri="{FF2B5EF4-FFF2-40B4-BE49-F238E27FC236}">
-                <a16:creationId xmlns:a16="http://schemas.microsoft.com/office/drawing/2014/main" id="{92B4C5BB-3185-422A-92EE-AD61F92685C0}"/>
-              </a:ext>
-            </a:extLst>
-          </p:cNvPr>
+          <p:cNvPr id="6" name="Slide Number Placeholder 5"/>
           <p:cNvSpPr>
             <a:spLocks noGrp="1"/>
           </p:cNvSpPr>
@@ -1196,7 +1534,7 @@
     </p:spTree>
     <p:extLst>
       <p:ext uri="{BB962C8B-B14F-4D97-AF65-F5344CB8AC3E}">
-        <p14:creationId xmlns:p14="http://schemas.microsoft.com/office/powerpoint/2010/main" val="3026244099"/>
+        <p14:creationId xmlns:p14="http://schemas.microsoft.com/office/powerpoint/2010/main" val="2551231618"/>
       </p:ext>
     </p:extLst>
   </p:cSld>
@@ -1225,13 +1563,7 @@
       </p:grpSpPr>
       <p:sp>
         <p:nvSpPr>
-          <p:cNvPr id="2" name="标题 1">
-            <a:extLst>
-              <a:ext uri="{FF2B5EF4-FFF2-40B4-BE49-F238E27FC236}">
-                <a16:creationId xmlns:a16="http://schemas.microsoft.com/office/drawing/2014/main" id="{39141CE9-262D-4573-8781-8334F899A24F}"/>
-              </a:ext>
-            </a:extLst>
-          </p:cNvPr>
+          <p:cNvPr id="2" name="Title 1"/>
           <p:cNvSpPr>
             <a:spLocks noGrp="1"/>
           </p:cNvSpPr>
@@ -1245,21 +1577,16 @@
           <a:lstStyle/>
           <a:p>
             <a:r>
-              <a:rPr lang="zh-CN" altLang="en-US"/>
+              <a:rPr lang="zh-CN" altLang="en-US" smtClean="0"/>
               <a:t>单击此处编辑母版标题样式</a:t>
             </a:r>
-          </a:p>
-        </p:txBody>
-      </p:sp>
-      <p:sp>
-        <p:nvSpPr>
-          <p:cNvPr id="3" name="内容占位符 2">
-            <a:extLst>
-              <a:ext uri="{FF2B5EF4-FFF2-40B4-BE49-F238E27FC236}">
-                <a16:creationId xmlns:a16="http://schemas.microsoft.com/office/drawing/2014/main" id="{150FFD55-BDAB-4F2F-9381-D24B4C02EADE}"/>
-              </a:ext>
-            </a:extLst>
-          </p:cNvPr>
+            <a:endParaRPr lang="en-US" dirty="0"/>
+          </a:p>
+        </p:txBody>
+      </p:sp>
+      <p:sp>
+        <p:nvSpPr>
+          <p:cNvPr id="3" name="Content Placeholder 2"/>
           <p:cNvSpPr>
             <a:spLocks noGrp="1"/>
           </p:cNvSpPr>
@@ -1269,8 +1596,8 @@
         </p:nvSpPr>
         <p:spPr>
           <a:xfrm>
-            <a:off x="838200" y="1825625"/>
-            <a:ext cx="5181600" cy="4351338"/>
+            <a:off x="517326" y="771242"/>
+            <a:ext cx="3198019" cy="1838239"/>
           </a:xfrm>
         </p:spPr>
         <p:txBody>
@@ -1279,49 +1606,44 @@
           <a:p>
             <a:pPr lvl="0"/>
             <a:r>
-              <a:rPr lang="zh-CN" altLang="en-US"/>
+              <a:rPr lang="zh-CN" altLang="en-US" smtClean="0"/>
               <a:t>编辑母版文本样式</a:t>
             </a:r>
           </a:p>
           <a:p>
             <a:pPr lvl="1"/>
             <a:r>
-              <a:rPr lang="zh-CN" altLang="en-US"/>
+              <a:rPr lang="zh-CN" altLang="en-US" smtClean="0"/>
               <a:t>第二级</a:t>
             </a:r>
           </a:p>
           <a:p>
             <a:pPr lvl="2"/>
             <a:r>
-              <a:rPr lang="zh-CN" altLang="en-US"/>
+              <a:rPr lang="zh-CN" altLang="en-US" smtClean="0"/>
               <a:t>第三级</a:t>
             </a:r>
           </a:p>
           <a:p>
             <a:pPr lvl="3"/>
             <a:r>
-              <a:rPr lang="zh-CN" altLang="en-US"/>
+              <a:rPr lang="zh-CN" altLang="en-US" smtClean="0"/>
               <a:t>第四级</a:t>
             </a:r>
           </a:p>
           <a:p>
             <a:pPr lvl="4"/>
             <a:r>
-              <a:rPr lang="zh-CN" altLang="en-US"/>
+              <a:rPr lang="zh-CN" altLang="en-US" smtClean="0"/>
               <a:t>第五级</a:t>
             </a:r>
-          </a:p>
-        </p:txBody>
-      </p:sp>
-      <p:sp>
-        <p:nvSpPr>
-          <p:cNvPr id="4" name="内容占位符 3">
-            <a:extLst>
-              <a:ext uri="{FF2B5EF4-FFF2-40B4-BE49-F238E27FC236}">
-                <a16:creationId xmlns:a16="http://schemas.microsoft.com/office/drawing/2014/main" id="{945F6FB7-C248-4D33-8C32-8127072C6743}"/>
-              </a:ext>
-            </a:extLst>
-          </p:cNvPr>
+            <a:endParaRPr lang="en-US" dirty="0"/>
+          </a:p>
+        </p:txBody>
+      </p:sp>
+      <p:sp>
+        <p:nvSpPr>
+          <p:cNvPr id="4" name="Content Placeholder 3"/>
           <p:cNvSpPr>
             <a:spLocks noGrp="1"/>
           </p:cNvSpPr>
@@ -1331,8 +1653,8 @@
         </p:nvSpPr>
         <p:spPr>
           <a:xfrm>
-            <a:off x="6172200" y="1825625"/>
-            <a:ext cx="5181600" cy="4351338"/>
+            <a:off x="3809405" y="771242"/>
+            <a:ext cx="3198019" cy="1838239"/>
           </a:xfrm>
         </p:spPr>
         <p:txBody>
@@ -1341,49 +1663,44 @@
           <a:p>
             <a:pPr lvl="0"/>
             <a:r>
-              <a:rPr lang="zh-CN" altLang="en-US"/>
+              <a:rPr lang="zh-CN" altLang="en-US" smtClean="0"/>
               <a:t>编辑母版文本样式</a:t>
             </a:r>
           </a:p>
           <a:p>
             <a:pPr lvl="1"/>
             <a:r>
-              <a:rPr lang="zh-CN" altLang="en-US"/>
+              <a:rPr lang="zh-CN" altLang="en-US" smtClean="0"/>
               <a:t>第二级</a:t>
             </a:r>
           </a:p>
           <a:p>
             <a:pPr lvl="2"/>
             <a:r>
-              <a:rPr lang="zh-CN" altLang="en-US"/>
+              <a:rPr lang="zh-CN" altLang="en-US" smtClean="0"/>
               <a:t>第三级</a:t>
             </a:r>
           </a:p>
           <a:p>
             <a:pPr lvl="3"/>
             <a:r>
-              <a:rPr lang="zh-CN" altLang="en-US"/>
+              <a:rPr lang="zh-CN" altLang="en-US" smtClean="0"/>
               <a:t>第四级</a:t>
             </a:r>
           </a:p>
           <a:p>
             <a:pPr lvl="4"/>
             <a:r>
-              <a:rPr lang="zh-CN" altLang="en-US"/>
+              <a:rPr lang="zh-CN" altLang="en-US" smtClean="0"/>
               <a:t>第五级</a:t>
             </a:r>
-          </a:p>
-        </p:txBody>
-      </p:sp>
-      <p:sp>
-        <p:nvSpPr>
-          <p:cNvPr id="5" name="日期占位符 4">
-            <a:extLst>
-              <a:ext uri="{FF2B5EF4-FFF2-40B4-BE49-F238E27FC236}">
-                <a16:creationId xmlns:a16="http://schemas.microsoft.com/office/drawing/2014/main" id="{DE5939F5-1E0C-47F7-B947-D805AAD0C385}"/>
-              </a:ext>
-            </a:extLst>
-          </p:cNvPr>
+            <a:endParaRPr lang="en-US" dirty="0"/>
+          </a:p>
+        </p:txBody>
+      </p:sp>
+      <p:sp>
+        <p:nvSpPr>
+          <p:cNvPr id="5" name="Date Placeholder 4"/>
           <p:cNvSpPr>
             <a:spLocks noGrp="1"/>
           </p:cNvSpPr>
@@ -1398,7 +1715,7 @@
           <a:p>
             <a:fld id="{86716E46-D677-4FA8-974A-5B989B436838}" type="datetimeFigureOut">
               <a:rPr lang="zh-CN" altLang="en-US" smtClean="0"/>
-              <a:t>2018/8/17</a:t>
+              <a:t>2021/04/02</a:t>
             </a:fld>
             <a:endParaRPr lang="zh-CN" altLang="en-US"/>
           </a:p>
@@ -1406,13 +1723,7 @@
       </p:sp>
       <p:sp>
         <p:nvSpPr>
-          <p:cNvPr id="6" name="页脚占位符 5">
-            <a:extLst>
-              <a:ext uri="{FF2B5EF4-FFF2-40B4-BE49-F238E27FC236}">
-                <a16:creationId xmlns:a16="http://schemas.microsoft.com/office/drawing/2014/main" id="{75B40084-DDB0-44E3-AEFC-226B29CC5B33}"/>
-              </a:ext>
-            </a:extLst>
-          </p:cNvPr>
+          <p:cNvPr id="6" name="Footer Placeholder 5"/>
           <p:cNvSpPr>
             <a:spLocks noGrp="1"/>
           </p:cNvSpPr>
@@ -1431,13 +1742,7 @@
       </p:sp>
       <p:sp>
         <p:nvSpPr>
-          <p:cNvPr id="7" name="灯片编号占位符 6">
-            <a:extLst>
-              <a:ext uri="{FF2B5EF4-FFF2-40B4-BE49-F238E27FC236}">
-                <a16:creationId xmlns:a16="http://schemas.microsoft.com/office/drawing/2014/main" id="{F7AA0CA0-107A-4E5F-8C86-71A2FC0B9C73}"/>
-              </a:ext>
-            </a:extLst>
-          </p:cNvPr>
+          <p:cNvPr id="7" name="Slide Number Placeholder 6"/>
           <p:cNvSpPr>
             <a:spLocks noGrp="1"/>
           </p:cNvSpPr>
@@ -1461,7 +1766,7 @@
     </p:spTree>
     <p:extLst>
       <p:ext uri="{BB962C8B-B14F-4D97-AF65-F5344CB8AC3E}">
-        <p14:creationId xmlns:p14="http://schemas.microsoft.com/office/powerpoint/2010/main" val="1913112084"/>
+        <p14:creationId xmlns:p14="http://schemas.microsoft.com/office/powerpoint/2010/main" val="1492368912"/>
       </p:ext>
     </p:extLst>
   </p:cSld>
@@ -1490,13 +1795,7 @@
       </p:grpSpPr>
       <p:sp>
         <p:nvSpPr>
-          <p:cNvPr id="2" name="标题 1">
-            <a:extLst>
-              <a:ext uri="{FF2B5EF4-FFF2-40B4-BE49-F238E27FC236}">
-                <a16:creationId xmlns:a16="http://schemas.microsoft.com/office/drawing/2014/main" id="{0A63E048-5905-429D-9A1E-8F2E8E8778DD}"/>
-              </a:ext>
-            </a:extLst>
-          </p:cNvPr>
+          <p:cNvPr id="2" name="Title 1"/>
           <p:cNvSpPr>
             <a:spLocks noGrp="1"/>
           </p:cNvSpPr>
@@ -1506,8 +1805,8 @@
         </p:nvSpPr>
         <p:spPr>
           <a:xfrm>
-            <a:off x="839788" y="365125"/>
-            <a:ext cx="10515600" cy="1325563"/>
+            <a:off x="518307" y="154249"/>
+            <a:ext cx="6490097" cy="559989"/>
           </a:xfrm>
         </p:spPr>
         <p:txBody>
@@ -1515,21 +1814,16 @@
           <a:lstStyle/>
           <a:p>
             <a:r>
-              <a:rPr lang="zh-CN" altLang="en-US"/>
+              <a:rPr lang="zh-CN" altLang="en-US" smtClean="0"/>
               <a:t>单击此处编辑母版标题样式</a:t>
             </a:r>
-          </a:p>
-        </p:txBody>
-      </p:sp>
-      <p:sp>
-        <p:nvSpPr>
-          <p:cNvPr id="3" name="文本占位符 2">
-            <a:extLst>
-              <a:ext uri="{FF2B5EF4-FFF2-40B4-BE49-F238E27FC236}">
-                <a16:creationId xmlns:a16="http://schemas.microsoft.com/office/drawing/2014/main" id="{48CEFB60-C266-4BD7-B3C2-D09D522AAD37}"/>
-              </a:ext>
-            </a:extLst>
-          </p:cNvPr>
+            <a:endParaRPr lang="en-US" dirty="0"/>
+          </a:p>
+        </p:txBody>
+      </p:sp>
+      <p:sp>
+        <p:nvSpPr>
+          <p:cNvPr id="3" name="Text Placeholder 2"/>
           <p:cNvSpPr>
             <a:spLocks noGrp="1"/>
           </p:cNvSpPr>
@@ -1539,8 +1833,8 @@
         </p:nvSpPr>
         <p:spPr>
           <a:xfrm>
-            <a:off x="839788" y="1681163"/>
-            <a:ext cx="5157787" cy="823912"/>
+            <a:off x="518307" y="710214"/>
+            <a:ext cx="3183322" cy="348065"/>
           </a:xfrm>
         </p:spPr>
         <p:txBody>
@@ -1548,45 +1842,45 @@
           <a:lstStyle>
             <a:lvl1pPr marL="0" indent="0">
               <a:buNone/>
-              <a:defRPr sz="2400" b="1"/>
+              <a:defRPr sz="1014" b="1"/>
             </a:lvl1pPr>
-            <a:lvl2pPr marL="457200" indent="0">
-              <a:buNone/>
-              <a:defRPr sz="2000" b="1"/>
+            <a:lvl2pPr marL="193167" indent="0">
+              <a:buNone/>
+              <a:defRPr sz="845" b="1"/>
             </a:lvl2pPr>
-            <a:lvl3pPr marL="914400" indent="0">
-              <a:buNone/>
-              <a:defRPr sz="1800" b="1"/>
+            <a:lvl3pPr marL="386334" indent="0">
+              <a:buNone/>
+              <a:defRPr sz="761" b="1"/>
             </a:lvl3pPr>
-            <a:lvl4pPr marL="1371600" indent="0">
-              <a:buNone/>
-              <a:defRPr sz="1600" b="1"/>
+            <a:lvl4pPr marL="579501" indent="0">
+              <a:buNone/>
+              <a:defRPr sz="676" b="1"/>
             </a:lvl4pPr>
-            <a:lvl5pPr marL="1828800" indent="0">
-              <a:buNone/>
-              <a:defRPr sz="1600" b="1"/>
+            <a:lvl5pPr marL="772668" indent="0">
+              <a:buNone/>
+              <a:defRPr sz="676" b="1"/>
             </a:lvl5pPr>
-            <a:lvl6pPr marL="2286000" indent="0">
-              <a:buNone/>
-              <a:defRPr sz="1600" b="1"/>
+            <a:lvl6pPr marL="965835" indent="0">
+              <a:buNone/>
+              <a:defRPr sz="676" b="1"/>
             </a:lvl6pPr>
-            <a:lvl7pPr marL="2743200" indent="0">
-              <a:buNone/>
-              <a:defRPr sz="1600" b="1"/>
+            <a:lvl7pPr marL="1159002" indent="0">
+              <a:buNone/>
+              <a:defRPr sz="676" b="1"/>
             </a:lvl7pPr>
-            <a:lvl8pPr marL="3200400" indent="0">
-              <a:buNone/>
-              <a:defRPr sz="1600" b="1"/>
+            <a:lvl8pPr marL="1352169" indent="0">
+              <a:buNone/>
+              <a:defRPr sz="676" b="1"/>
             </a:lvl8pPr>
-            <a:lvl9pPr marL="3657600" indent="0">
-              <a:buNone/>
-              <a:defRPr sz="1600" b="1"/>
+            <a:lvl9pPr marL="1545336" indent="0">
+              <a:buNone/>
+              <a:defRPr sz="676" b="1"/>
             </a:lvl9pPr>
           </a:lstStyle>
           <a:p>
             <a:pPr lvl="0"/>
             <a:r>
-              <a:rPr lang="zh-CN" altLang="en-US"/>
+              <a:rPr lang="zh-CN" altLang="en-US" smtClean="0"/>
               <a:t>编辑母版文本样式</a:t>
             </a:r>
           </a:p>
@@ -1594,13 +1888,7 @@
       </p:sp>
       <p:sp>
         <p:nvSpPr>
-          <p:cNvPr id="4" name="内容占位符 3">
-            <a:extLst>
-              <a:ext uri="{FF2B5EF4-FFF2-40B4-BE49-F238E27FC236}">
-                <a16:creationId xmlns:a16="http://schemas.microsoft.com/office/drawing/2014/main" id="{08905D49-D8AF-453F-833B-9267761A3BD4}"/>
-              </a:ext>
-            </a:extLst>
-          </p:cNvPr>
+          <p:cNvPr id="4" name="Content Placeholder 3"/>
           <p:cNvSpPr>
             <a:spLocks noGrp="1"/>
           </p:cNvSpPr>
@@ -1610,8 +1898,8 @@
         </p:nvSpPr>
         <p:spPr>
           <a:xfrm>
-            <a:off x="839788" y="2505075"/>
-            <a:ext cx="5157787" cy="3684588"/>
+            <a:off x="518307" y="1058278"/>
+            <a:ext cx="3183322" cy="1556568"/>
           </a:xfrm>
         </p:spPr>
         <p:txBody>
@@ -1620,49 +1908,44 @@
           <a:p>
             <a:pPr lvl="0"/>
             <a:r>
-              <a:rPr lang="zh-CN" altLang="en-US"/>
+              <a:rPr lang="zh-CN" altLang="en-US" smtClean="0"/>
               <a:t>编辑母版文本样式</a:t>
             </a:r>
           </a:p>
           <a:p>
             <a:pPr lvl="1"/>
             <a:r>
-              <a:rPr lang="zh-CN" altLang="en-US"/>
+              <a:rPr lang="zh-CN" altLang="en-US" smtClean="0"/>
               <a:t>第二级</a:t>
             </a:r>
           </a:p>
           <a:p>
             <a:pPr lvl="2"/>
             <a:r>
-              <a:rPr lang="zh-CN" altLang="en-US"/>
+              <a:rPr lang="zh-CN" altLang="en-US" smtClean="0"/>
               <a:t>第三级</a:t>
             </a:r>
           </a:p>
           <a:p>
             <a:pPr lvl="3"/>
             <a:r>
-              <a:rPr lang="zh-CN" altLang="en-US"/>
+              <a:rPr lang="zh-CN" altLang="en-US" smtClean="0"/>
               <a:t>第四级</a:t>
             </a:r>
           </a:p>
           <a:p>
             <a:pPr lvl="4"/>
             <a:r>
-              <a:rPr lang="zh-CN" altLang="en-US"/>
+              <a:rPr lang="zh-CN" altLang="en-US" smtClean="0"/>
               <a:t>第五级</a:t>
             </a:r>
-          </a:p>
-        </p:txBody>
-      </p:sp>
-      <p:sp>
-        <p:nvSpPr>
-          <p:cNvPr id="5" name="文本占位符 4">
-            <a:extLst>
-              <a:ext uri="{FF2B5EF4-FFF2-40B4-BE49-F238E27FC236}">
-                <a16:creationId xmlns:a16="http://schemas.microsoft.com/office/drawing/2014/main" id="{87A729BC-44F2-4528-A899-AEA366B25630}"/>
-              </a:ext>
-            </a:extLst>
-          </p:cNvPr>
+            <a:endParaRPr lang="en-US" dirty="0"/>
+          </a:p>
+        </p:txBody>
+      </p:sp>
+      <p:sp>
+        <p:nvSpPr>
+          <p:cNvPr id="5" name="Text Placeholder 4"/>
           <p:cNvSpPr>
             <a:spLocks noGrp="1"/>
           </p:cNvSpPr>
@@ -1672,8 +1955,8 @@
         </p:nvSpPr>
         <p:spPr>
           <a:xfrm>
-            <a:off x="6172200" y="1681163"/>
-            <a:ext cx="5183188" cy="823912"/>
+            <a:off x="3809405" y="710214"/>
+            <a:ext cx="3198999" cy="348065"/>
           </a:xfrm>
         </p:spPr>
         <p:txBody>
@@ -1681,45 +1964,45 @@
           <a:lstStyle>
             <a:lvl1pPr marL="0" indent="0">
               <a:buNone/>
-              <a:defRPr sz="2400" b="1"/>
+              <a:defRPr sz="1014" b="1"/>
             </a:lvl1pPr>
-            <a:lvl2pPr marL="457200" indent="0">
-              <a:buNone/>
-              <a:defRPr sz="2000" b="1"/>
+            <a:lvl2pPr marL="193167" indent="0">
+              <a:buNone/>
+              <a:defRPr sz="845" b="1"/>
             </a:lvl2pPr>
-            <a:lvl3pPr marL="914400" indent="0">
-              <a:buNone/>
-              <a:defRPr sz="1800" b="1"/>
+            <a:lvl3pPr marL="386334" indent="0">
+              <a:buNone/>
+              <a:defRPr sz="761" b="1"/>
             </a:lvl3pPr>
-            <a:lvl4pPr marL="1371600" indent="0">
-              <a:buNone/>
-              <a:defRPr sz="1600" b="1"/>
+            <a:lvl4pPr marL="579501" indent="0">
+              <a:buNone/>
+              <a:defRPr sz="676" b="1"/>
             </a:lvl4pPr>
-            <a:lvl5pPr marL="1828800" indent="0">
-              <a:buNone/>
-              <a:defRPr sz="1600" b="1"/>
+            <a:lvl5pPr marL="772668" indent="0">
+              <a:buNone/>
+              <a:defRPr sz="676" b="1"/>
             </a:lvl5pPr>
-            <a:lvl6pPr marL="2286000" indent="0">
-              <a:buNone/>
-              <a:defRPr sz="1600" b="1"/>
+            <a:lvl6pPr marL="965835" indent="0">
+              <a:buNone/>
+              <a:defRPr sz="676" b="1"/>
             </a:lvl6pPr>
-            <a:lvl7pPr marL="2743200" indent="0">
-              <a:buNone/>
-              <a:defRPr sz="1600" b="1"/>
+            <a:lvl7pPr marL="1159002" indent="0">
+              <a:buNone/>
+              <a:defRPr sz="676" b="1"/>
             </a:lvl7pPr>
-            <a:lvl8pPr marL="3200400" indent="0">
-              <a:buNone/>
-              <a:defRPr sz="1600" b="1"/>
+            <a:lvl8pPr marL="1352169" indent="0">
+              <a:buNone/>
+              <a:defRPr sz="676" b="1"/>
             </a:lvl8pPr>
-            <a:lvl9pPr marL="3657600" indent="0">
-              <a:buNone/>
-              <a:defRPr sz="1600" b="1"/>
+            <a:lvl9pPr marL="1545336" indent="0">
+              <a:buNone/>
+              <a:defRPr sz="676" b="1"/>
             </a:lvl9pPr>
           </a:lstStyle>
           <a:p>
             <a:pPr lvl="0"/>
             <a:r>
-              <a:rPr lang="zh-CN" altLang="en-US"/>
+              <a:rPr lang="zh-CN" altLang="en-US" smtClean="0"/>
               <a:t>编辑母版文本样式</a:t>
             </a:r>
           </a:p>
@@ -1727,13 +2010,7 @@
       </p:sp>
       <p:sp>
         <p:nvSpPr>
-          <p:cNvPr id="6" name="内容占位符 5">
-            <a:extLst>
-              <a:ext uri="{FF2B5EF4-FFF2-40B4-BE49-F238E27FC236}">
-                <a16:creationId xmlns:a16="http://schemas.microsoft.com/office/drawing/2014/main" id="{704F0DE2-4833-4269-A6AF-2C2D4EA0D306}"/>
-              </a:ext>
-            </a:extLst>
-          </p:cNvPr>
+          <p:cNvPr id="6" name="Content Placeholder 5"/>
           <p:cNvSpPr>
             <a:spLocks noGrp="1"/>
           </p:cNvSpPr>
@@ -1743,8 +2020,8 @@
         </p:nvSpPr>
         <p:spPr>
           <a:xfrm>
-            <a:off x="6172200" y="2505075"/>
-            <a:ext cx="5183188" cy="3684588"/>
+            <a:off x="3809405" y="1058278"/>
+            <a:ext cx="3198999" cy="1556568"/>
           </a:xfrm>
         </p:spPr>
         <p:txBody>
@@ -1753,49 +2030,44 @@
           <a:p>
             <a:pPr lvl="0"/>
             <a:r>
-              <a:rPr lang="zh-CN" altLang="en-US"/>
+              <a:rPr lang="zh-CN" altLang="en-US" smtClean="0"/>
               <a:t>编辑母版文本样式</a:t>
             </a:r>
           </a:p>
           <a:p>
             <a:pPr lvl="1"/>
             <a:r>
-              <a:rPr lang="zh-CN" altLang="en-US"/>
+              <a:rPr lang="zh-CN" altLang="en-US" smtClean="0"/>
               <a:t>第二级</a:t>
             </a:r>
           </a:p>
           <a:p>
             <a:pPr lvl="2"/>
             <a:r>
-              <a:rPr lang="zh-CN" altLang="en-US"/>
+              <a:rPr lang="zh-CN" altLang="en-US" smtClean="0"/>
               <a:t>第三级</a:t>
             </a:r>
           </a:p>
           <a:p>
             <a:pPr lvl="3"/>
             <a:r>
-              <a:rPr lang="zh-CN" altLang="en-US"/>
+              <a:rPr lang="zh-CN" altLang="en-US" smtClean="0"/>
               <a:t>第四级</a:t>
             </a:r>
           </a:p>
           <a:p>
             <a:pPr lvl="4"/>
             <a:r>
-              <a:rPr lang="zh-CN" altLang="en-US"/>
+              <a:rPr lang="zh-CN" altLang="en-US" smtClean="0"/>
               <a:t>第五级</a:t>
             </a:r>
-          </a:p>
-        </p:txBody>
-      </p:sp>
-      <p:sp>
-        <p:nvSpPr>
-          <p:cNvPr id="7" name="日期占位符 6">
-            <a:extLst>
-              <a:ext uri="{FF2B5EF4-FFF2-40B4-BE49-F238E27FC236}">
-                <a16:creationId xmlns:a16="http://schemas.microsoft.com/office/drawing/2014/main" id="{9EF0F179-8652-4DE6-884F-FB4DD93131F2}"/>
-              </a:ext>
-            </a:extLst>
-          </p:cNvPr>
+            <a:endParaRPr lang="en-US" dirty="0"/>
+          </a:p>
+        </p:txBody>
+      </p:sp>
+      <p:sp>
+        <p:nvSpPr>
+          <p:cNvPr id="7" name="Date Placeholder 6"/>
           <p:cNvSpPr>
             <a:spLocks noGrp="1"/>
           </p:cNvSpPr>
@@ -1810,7 +2082,7 @@
           <a:p>
             <a:fld id="{86716E46-D677-4FA8-974A-5B989B436838}" type="datetimeFigureOut">
               <a:rPr lang="zh-CN" altLang="en-US" smtClean="0"/>
-              <a:t>2018/8/17</a:t>
+              <a:t>2021/04/02</a:t>
             </a:fld>
             <a:endParaRPr lang="zh-CN" altLang="en-US"/>
           </a:p>
@@ -1818,13 +2090,7 @@
       </p:sp>
       <p:sp>
         <p:nvSpPr>
-          <p:cNvPr id="8" name="页脚占位符 7">
-            <a:extLst>
-              <a:ext uri="{FF2B5EF4-FFF2-40B4-BE49-F238E27FC236}">
-                <a16:creationId xmlns:a16="http://schemas.microsoft.com/office/drawing/2014/main" id="{1CCDBDAF-8511-4F06-935A-472AB0A66F70}"/>
-              </a:ext>
-            </a:extLst>
-          </p:cNvPr>
+          <p:cNvPr id="8" name="Footer Placeholder 7"/>
           <p:cNvSpPr>
             <a:spLocks noGrp="1"/>
           </p:cNvSpPr>
@@ -1843,13 +2109,7 @@
       </p:sp>
       <p:sp>
         <p:nvSpPr>
-          <p:cNvPr id="9" name="灯片编号占位符 8">
-            <a:extLst>
-              <a:ext uri="{FF2B5EF4-FFF2-40B4-BE49-F238E27FC236}">
-                <a16:creationId xmlns:a16="http://schemas.microsoft.com/office/drawing/2014/main" id="{B1FDBD7C-D83C-4632-9EBD-B8CCCA03B1B2}"/>
-              </a:ext>
-            </a:extLst>
-          </p:cNvPr>
+          <p:cNvPr id="9" name="Slide Number Placeholder 8"/>
           <p:cNvSpPr>
             <a:spLocks noGrp="1"/>
           </p:cNvSpPr>
@@ -1873,7 +2133,7 @@
     </p:spTree>
     <p:extLst>
       <p:ext uri="{BB962C8B-B14F-4D97-AF65-F5344CB8AC3E}">
-        <p14:creationId xmlns:p14="http://schemas.microsoft.com/office/powerpoint/2010/main" val="2724014319"/>
+        <p14:creationId xmlns:p14="http://schemas.microsoft.com/office/powerpoint/2010/main" val="458673408"/>
       </p:ext>
     </p:extLst>
   </p:cSld>
@@ -1902,13 +2162,7 @@
       </p:grpSpPr>
       <p:sp>
         <p:nvSpPr>
-          <p:cNvPr id="2" name="标题 1">
-            <a:extLst>
-              <a:ext uri="{FF2B5EF4-FFF2-40B4-BE49-F238E27FC236}">
-                <a16:creationId xmlns:a16="http://schemas.microsoft.com/office/drawing/2014/main" id="{08252B8C-D1A2-46EA-821E-D8DFC957D1FB}"/>
-              </a:ext>
-            </a:extLst>
-          </p:cNvPr>
+          <p:cNvPr id="2" name="Title 1"/>
           <p:cNvSpPr>
             <a:spLocks noGrp="1"/>
           </p:cNvSpPr>
@@ -1922,21 +2176,16 @@
           <a:lstStyle/>
           <a:p>
             <a:r>
-              <a:rPr lang="zh-CN" altLang="en-US"/>
+              <a:rPr lang="zh-CN" altLang="en-US" smtClean="0"/>
               <a:t>单击此处编辑母版标题样式</a:t>
             </a:r>
-          </a:p>
-        </p:txBody>
-      </p:sp>
-      <p:sp>
-        <p:nvSpPr>
-          <p:cNvPr id="3" name="日期占位符 2">
-            <a:extLst>
-              <a:ext uri="{FF2B5EF4-FFF2-40B4-BE49-F238E27FC236}">
-                <a16:creationId xmlns:a16="http://schemas.microsoft.com/office/drawing/2014/main" id="{21B4F0C8-FD13-407C-AEB9-963962266490}"/>
-              </a:ext>
-            </a:extLst>
-          </p:cNvPr>
+            <a:endParaRPr lang="en-US" dirty="0"/>
+          </a:p>
+        </p:txBody>
+      </p:sp>
+      <p:sp>
+        <p:nvSpPr>
+          <p:cNvPr id="3" name="Date Placeholder 2"/>
           <p:cNvSpPr>
             <a:spLocks noGrp="1"/>
           </p:cNvSpPr>
@@ -1951,7 +2200,7 @@
           <a:p>
             <a:fld id="{86716E46-D677-4FA8-974A-5B989B436838}" type="datetimeFigureOut">
               <a:rPr lang="zh-CN" altLang="en-US" smtClean="0"/>
-              <a:t>2018/8/17</a:t>
+              <a:t>2021/04/02</a:t>
             </a:fld>
             <a:endParaRPr lang="zh-CN" altLang="en-US"/>
           </a:p>
@@ -1959,13 +2208,7 @@
       </p:sp>
       <p:sp>
         <p:nvSpPr>
-          <p:cNvPr id="4" name="页脚占位符 3">
-            <a:extLst>
-              <a:ext uri="{FF2B5EF4-FFF2-40B4-BE49-F238E27FC236}">
-                <a16:creationId xmlns:a16="http://schemas.microsoft.com/office/drawing/2014/main" id="{E80A1CEB-319A-447D-A00D-C5DCE87938A6}"/>
-              </a:ext>
-            </a:extLst>
-          </p:cNvPr>
+          <p:cNvPr id="4" name="Footer Placeholder 3"/>
           <p:cNvSpPr>
             <a:spLocks noGrp="1"/>
           </p:cNvSpPr>
@@ -1984,13 +2227,7 @@
       </p:sp>
       <p:sp>
         <p:nvSpPr>
-          <p:cNvPr id="5" name="灯片编号占位符 4">
-            <a:extLst>
-              <a:ext uri="{FF2B5EF4-FFF2-40B4-BE49-F238E27FC236}">
-                <a16:creationId xmlns:a16="http://schemas.microsoft.com/office/drawing/2014/main" id="{DA9C3FED-3EAB-477D-BF21-48C708B3BABA}"/>
-              </a:ext>
-            </a:extLst>
-          </p:cNvPr>
+          <p:cNvPr id="5" name="Slide Number Placeholder 4"/>
           <p:cNvSpPr>
             <a:spLocks noGrp="1"/>
           </p:cNvSpPr>
@@ -2014,7 +2251,7 @@
     </p:spTree>
     <p:extLst>
       <p:ext uri="{BB962C8B-B14F-4D97-AF65-F5344CB8AC3E}">
-        <p14:creationId xmlns:p14="http://schemas.microsoft.com/office/powerpoint/2010/main" val="3397693853"/>
+        <p14:creationId xmlns:p14="http://schemas.microsoft.com/office/powerpoint/2010/main" val="434852257"/>
       </p:ext>
     </p:extLst>
   </p:cSld>
@@ -2043,13 +2280,7 @@
       </p:grpSpPr>
       <p:sp>
         <p:nvSpPr>
-          <p:cNvPr id="2" name="日期占位符 1">
-            <a:extLst>
-              <a:ext uri="{FF2B5EF4-FFF2-40B4-BE49-F238E27FC236}">
-                <a16:creationId xmlns:a16="http://schemas.microsoft.com/office/drawing/2014/main" id="{D982B719-8FB6-4599-9918-5E09D9E8F7D3}"/>
-              </a:ext>
-            </a:extLst>
-          </p:cNvPr>
+          <p:cNvPr id="2" name="Date Placeholder 1"/>
           <p:cNvSpPr>
             <a:spLocks noGrp="1"/>
           </p:cNvSpPr>
@@ -2064,7 +2295,7 @@
           <a:p>
             <a:fld id="{86716E46-D677-4FA8-974A-5B989B436838}" type="datetimeFigureOut">
               <a:rPr lang="zh-CN" altLang="en-US" smtClean="0"/>
-              <a:t>2018/8/17</a:t>
+              <a:t>2021/04/02</a:t>
             </a:fld>
             <a:endParaRPr lang="zh-CN" altLang="en-US"/>
           </a:p>
@@ -2072,13 +2303,7 @@
       </p:sp>
       <p:sp>
         <p:nvSpPr>
-          <p:cNvPr id="3" name="页脚占位符 2">
-            <a:extLst>
-              <a:ext uri="{FF2B5EF4-FFF2-40B4-BE49-F238E27FC236}">
-                <a16:creationId xmlns:a16="http://schemas.microsoft.com/office/drawing/2014/main" id="{C1C32C5A-559B-43BC-A308-FC060F37E932}"/>
-              </a:ext>
-            </a:extLst>
-          </p:cNvPr>
+          <p:cNvPr id="3" name="Footer Placeholder 2"/>
           <p:cNvSpPr>
             <a:spLocks noGrp="1"/>
           </p:cNvSpPr>
@@ -2097,13 +2322,7 @@
       </p:sp>
       <p:sp>
         <p:nvSpPr>
-          <p:cNvPr id="4" name="灯片编号占位符 3">
-            <a:extLst>
-              <a:ext uri="{FF2B5EF4-FFF2-40B4-BE49-F238E27FC236}">
-                <a16:creationId xmlns:a16="http://schemas.microsoft.com/office/drawing/2014/main" id="{E1DF7D8A-B927-4373-8888-14C2417D390D}"/>
-              </a:ext>
-            </a:extLst>
-          </p:cNvPr>
+          <p:cNvPr id="4" name="Slide Number Placeholder 3"/>
           <p:cNvSpPr>
             <a:spLocks noGrp="1"/>
           </p:cNvSpPr>
@@ -2127,7 +2346,7 @@
     </p:spTree>
     <p:extLst>
       <p:ext uri="{BB962C8B-B14F-4D97-AF65-F5344CB8AC3E}">
-        <p14:creationId xmlns:p14="http://schemas.microsoft.com/office/powerpoint/2010/main" val="2600992114"/>
+        <p14:creationId xmlns:p14="http://schemas.microsoft.com/office/powerpoint/2010/main" val="1233907184"/>
       </p:ext>
     </p:extLst>
   </p:cSld>
@@ -2156,13 +2375,7 @@
       </p:grpSpPr>
       <p:sp>
         <p:nvSpPr>
-          <p:cNvPr id="2" name="标题 1">
-            <a:extLst>
-              <a:ext uri="{FF2B5EF4-FFF2-40B4-BE49-F238E27FC236}">
-                <a16:creationId xmlns:a16="http://schemas.microsoft.com/office/drawing/2014/main" id="{4425C3EC-72C3-48F5-BD82-7D9D3BF5370E}"/>
-              </a:ext>
-            </a:extLst>
-          </p:cNvPr>
+          <p:cNvPr id="2" name="Title 1"/>
           <p:cNvSpPr>
             <a:spLocks noGrp="1"/>
           </p:cNvSpPr>
@@ -2172,34 +2385,29 @@
         </p:nvSpPr>
         <p:spPr>
           <a:xfrm>
-            <a:off x="839788" y="457200"/>
-            <a:ext cx="3932237" cy="1600200"/>
+            <a:off x="518307" y="193146"/>
+            <a:ext cx="2426928" cy="676011"/>
           </a:xfrm>
         </p:spPr>
         <p:txBody>
           <a:bodyPr anchor="b"/>
           <a:lstStyle>
             <a:lvl1pPr>
-              <a:defRPr sz="3200"/>
+              <a:defRPr sz="1352"/>
             </a:lvl1pPr>
           </a:lstStyle>
           <a:p>
             <a:r>
-              <a:rPr lang="zh-CN" altLang="en-US"/>
+              <a:rPr lang="zh-CN" altLang="en-US" smtClean="0"/>
               <a:t>单击此处编辑母版标题样式</a:t>
             </a:r>
-          </a:p>
-        </p:txBody>
-      </p:sp>
-      <p:sp>
-        <p:nvSpPr>
-          <p:cNvPr id="3" name="内容占位符 2">
-            <a:extLst>
-              <a:ext uri="{FF2B5EF4-FFF2-40B4-BE49-F238E27FC236}">
-                <a16:creationId xmlns:a16="http://schemas.microsoft.com/office/drawing/2014/main" id="{4A44BEC5-9BCA-4522-A937-E47677F9CE33}"/>
-              </a:ext>
-            </a:extLst>
-          </p:cNvPr>
+            <a:endParaRPr lang="en-US" dirty="0"/>
+          </a:p>
+        </p:txBody>
+      </p:sp>
+      <p:sp>
+        <p:nvSpPr>
+          <p:cNvPr id="3" name="Content Placeholder 2"/>
           <p:cNvSpPr>
             <a:spLocks noGrp="1"/>
           </p:cNvSpPr>
@@ -2209,87 +2417,82 @@
         </p:nvSpPr>
         <p:spPr>
           <a:xfrm>
-            <a:off x="5183188" y="987425"/>
-            <a:ext cx="6172200" cy="4873625"/>
+            <a:off x="3198999" y="417142"/>
+            <a:ext cx="3809405" cy="2058881"/>
           </a:xfrm>
         </p:spPr>
         <p:txBody>
           <a:bodyPr/>
           <a:lstStyle>
             <a:lvl1pPr>
-              <a:defRPr sz="3200"/>
+              <a:defRPr sz="1352"/>
             </a:lvl1pPr>
             <a:lvl2pPr>
-              <a:defRPr sz="2800"/>
+              <a:defRPr sz="1183"/>
             </a:lvl2pPr>
             <a:lvl3pPr>
-              <a:defRPr sz="2400"/>
+              <a:defRPr sz="1014"/>
             </a:lvl3pPr>
             <a:lvl4pPr>
-              <a:defRPr sz="2000"/>
+              <a:defRPr sz="845"/>
             </a:lvl4pPr>
             <a:lvl5pPr>
-              <a:defRPr sz="2000"/>
+              <a:defRPr sz="845"/>
             </a:lvl5pPr>
             <a:lvl6pPr>
-              <a:defRPr sz="2000"/>
+              <a:defRPr sz="845"/>
             </a:lvl6pPr>
             <a:lvl7pPr>
-              <a:defRPr sz="2000"/>
+              <a:defRPr sz="845"/>
             </a:lvl7pPr>
             <a:lvl8pPr>
-              <a:defRPr sz="2000"/>
+              <a:defRPr sz="845"/>
             </a:lvl8pPr>
             <a:lvl9pPr>
-              <a:defRPr sz="2000"/>
+              <a:defRPr sz="845"/>
             </a:lvl9pPr>
           </a:lstStyle>
           <a:p>
             <a:pPr lvl="0"/>
             <a:r>
-              <a:rPr lang="zh-CN" altLang="en-US"/>
+              <a:rPr lang="zh-CN" altLang="en-US" smtClean="0"/>
               <a:t>编辑母版文本样式</a:t>
             </a:r>
           </a:p>
           <a:p>
             <a:pPr lvl="1"/>
             <a:r>
-              <a:rPr lang="zh-CN" altLang="en-US"/>
+              <a:rPr lang="zh-CN" altLang="en-US" smtClean="0"/>
               <a:t>第二级</a:t>
             </a:r>
           </a:p>
           <a:p>
             <a:pPr lvl="2"/>
             <a:r>
-              <a:rPr lang="zh-CN" altLang="en-US"/>
+              <a:rPr lang="zh-CN" altLang="en-US" smtClean="0"/>
               <a:t>第三级</a:t>
             </a:r>
           </a:p>
           <a:p>
             <a:pPr lvl="3"/>
             <a:r>
-              <a:rPr lang="zh-CN" altLang="en-US"/>
+              <a:rPr lang="zh-CN" altLang="en-US" smtClean="0"/>
               <a:t>第四级</a:t>
             </a:r>
           </a:p>
           <a:p>
             <a:pPr lvl="4"/>
             <a:r>
-              <a:rPr lang="zh-CN" altLang="en-US"/>
+              <a:rPr lang="zh-CN" altLang="en-US" smtClean="0"/>
               <a:t>第五级</a:t>
             </a:r>
-          </a:p>
-        </p:txBody>
-      </p:sp>
-      <p:sp>
-        <p:nvSpPr>
-          <p:cNvPr id="4" name="文本占位符 3">
-            <a:extLst>
-              <a:ext uri="{FF2B5EF4-FFF2-40B4-BE49-F238E27FC236}">
-                <a16:creationId xmlns:a16="http://schemas.microsoft.com/office/drawing/2014/main" id="{03460D1E-EDDC-424F-AF79-265DF635453B}"/>
-              </a:ext>
-            </a:extLst>
-          </p:cNvPr>
+            <a:endParaRPr lang="en-US" dirty="0"/>
+          </a:p>
+        </p:txBody>
+      </p:sp>
+      <p:sp>
+        <p:nvSpPr>
+          <p:cNvPr id="4" name="Text Placeholder 3"/>
           <p:cNvSpPr>
             <a:spLocks noGrp="1"/>
           </p:cNvSpPr>
@@ -2299,8 +2502,8 @@
         </p:nvSpPr>
         <p:spPr>
           <a:xfrm>
-            <a:off x="839788" y="2057400"/>
-            <a:ext cx="3932237" cy="3811588"/>
+            <a:off x="518307" y="869156"/>
+            <a:ext cx="2426928" cy="1610220"/>
           </a:xfrm>
         </p:spPr>
         <p:txBody>
@@ -2308,45 +2511,45 @@
           <a:lstStyle>
             <a:lvl1pPr marL="0" indent="0">
               <a:buNone/>
-              <a:defRPr sz="1600"/>
+              <a:defRPr sz="676"/>
             </a:lvl1pPr>
-            <a:lvl2pPr marL="457200" indent="0">
-              <a:buNone/>
-              <a:defRPr sz="1400"/>
+            <a:lvl2pPr marL="193167" indent="0">
+              <a:buNone/>
+              <a:defRPr sz="592"/>
             </a:lvl2pPr>
-            <a:lvl3pPr marL="914400" indent="0">
-              <a:buNone/>
-              <a:defRPr sz="1200"/>
+            <a:lvl3pPr marL="386334" indent="0">
+              <a:buNone/>
+              <a:defRPr sz="507"/>
             </a:lvl3pPr>
-            <a:lvl4pPr marL="1371600" indent="0">
-              <a:buNone/>
-              <a:defRPr sz="1000"/>
+            <a:lvl4pPr marL="579501" indent="0">
+              <a:buNone/>
+              <a:defRPr sz="422"/>
             </a:lvl4pPr>
-            <a:lvl5pPr marL="1828800" indent="0">
-              <a:buNone/>
-              <a:defRPr sz="1000"/>
+            <a:lvl5pPr marL="772668" indent="0">
+              <a:buNone/>
+              <a:defRPr sz="422"/>
             </a:lvl5pPr>
-            <a:lvl6pPr marL="2286000" indent="0">
-              <a:buNone/>
-              <a:defRPr sz="1000"/>
+            <a:lvl6pPr marL="965835" indent="0">
+              <a:buNone/>
+              <a:defRPr sz="422"/>
             </a:lvl6pPr>
-            <a:lvl7pPr marL="2743200" indent="0">
-              <a:buNone/>
-              <a:defRPr sz="1000"/>
+            <a:lvl7pPr marL="1159002" indent="0">
+              <a:buNone/>
+              <a:defRPr sz="422"/>
             </a:lvl7pPr>
-            <a:lvl8pPr marL="3200400" indent="0">
-              <a:buNone/>
-              <a:defRPr sz="1000"/>
+            <a:lvl8pPr marL="1352169" indent="0">
+              <a:buNone/>
+              <a:defRPr sz="422"/>
             </a:lvl8pPr>
-            <a:lvl9pPr marL="3657600" indent="0">
-              <a:buNone/>
-              <a:defRPr sz="1000"/>
+            <a:lvl9pPr marL="1545336" indent="0">
+              <a:buNone/>
+              <a:defRPr sz="422"/>
             </a:lvl9pPr>
           </a:lstStyle>
           <a:p>
             <a:pPr lvl="0"/>
             <a:r>
-              <a:rPr lang="zh-CN" altLang="en-US"/>
+              <a:rPr lang="zh-CN" altLang="en-US" smtClean="0"/>
               <a:t>编辑母版文本样式</a:t>
             </a:r>
           </a:p>
@@ -2354,13 +2557,7 @@
       </p:sp>
       <p:sp>
         <p:nvSpPr>
-          <p:cNvPr id="5" name="日期占位符 4">
-            <a:extLst>
-              <a:ext uri="{FF2B5EF4-FFF2-40B4-BE49-F238E27FC236}">
-                <a16:creationId xmlns:a16="http://schemas.microsoft.com/office/drawing/2014/main" id="{3D55B7CD-93AB-4214-B608-9C3F48593B98}"/>
-              </a:ext>
-            </a:extLst>
-          </p:cNvPr>
+          <p:cNvPr id="5" name="Date Placeholder 4"/>
           <p:cNvSpPr>
             <a:spLocks noGrp="1"/>
           </p:cNvSpPr>
@@ -2375,7 +2572,7 @@
           <a:p>
             <a:fld id="{86716E46-D677-4FA8-974A-5B989B436838}" type="datetimeFigureOut">
               <a:rPr lang="zh-CN" altLang="en-US" smtClean="0"/>
-              <a:t>2018/8/17</a:t>
+              <a:t>2021/04/02</a:t>
             </a:fld>
             <a:endParaRPr lang="zh-CN" altLang="en-US"/>
           </a:p>
@@ -2383,13 +2580,7 @@
       </p:sp>
       <p:sp>
         <p:nvSpPr>
-          <p:cNvPr id="6" name="页脚占位符 5">
-            <a:extLst>
-              <a:ext uri="{FF2B5EF4-FFF2-40B4-BE49-F238E27FC236}">
-                <a16:creationId xmlns:a16="http://schemas.microsoft.com/office/drawing/2014/main" id="{78C424E0-BA21-48CF-B511-631D6F812F92}"/>
-              </a:ext>
-            </a:extLst>
-          </p:cNvPr>
+          <p:cNvPr id="6" name="Footer Placeholder 5"/>
           <p:cNvSpPr>
             <a:spLocks noGrp="1"/>
           </p:cNvSpPr>
@@ -2408,13 +2599,7 @@
       </p:sp>
       <p:sp>
         <p:nvSpPr>
-          <p:cNvPr id="7" name="灯片编号占位符 6">
-            <a:extLst>
-              <a:ext uri="{FF2B5EF4-FFF2-40B4-BE49-F238E27FC236}">
-                <a16:creationId xmlns:a16="http://schemas.microsoft.com/office/drawing/2014/main" id="{E0B5DDBB-B5C0-423D-9B1F-EAFC6384586F}"/>
-              </a:ext>
-            </a:extLst>
-          </p:cNvPr>
+          <p:cNvPr id="7" name="Slide Number Placeholder 6"/>
           <p:cNvSpPr>
             <a:spLocks noGrp="1"/>
           </p:cNvSpPr>
@@ -2438,7 +2623,7 @@
     </p:spTree>
     <p:extLst>
       <p:ext uri="{BB962C8B-B14F-4D97-AF65-F5344CB8AC3E}">
-        <p14:creationId xmlns:p14="http://schemas.microsoft.com/office/powerpoint/2010/main" val="4027278226"/>
+        <p14:creationId xmlns:p14="http://schemas.microsoft.com/office/powerpoint/2010/main" val="302827668"/>
       </p:ext>
     </p:extLst>
   </p:cSld>
@@ -2467,13 +2652,7 @@
       </p:grpSpPr>
       <p:sp>
         <p:nvSpPr>
-          <p:cNvPr id="2" name="标题 1">
-            <a:extLst>
-              <a:ext uri="{FF2B5EF4-FFF2-40B4-BE49-F238E27FC236}">
-                <a16:creationId xmlns:a16="http://schemas.microsoft.com/office/drawing/2014/main" id="{F1104979-F47E-46C9-9EF9-13B465DCC3E2}"/>
-              </a:ext>
-            </a:extLst>
-          </p:cNvPr>
+          <p:cNvPr id="2" name="Title 1"/>
           <p:cNvSpPr>
             <a:spLocks noGrp="1"/>
           </p:cNvSpPr>
@@ -2483,36 +2662,31 @@
         </p:nvSpPr>
         <p:spPr>
           <a:xfrm>
-            <a:off x="839788" y="457200"/>
-            <a:ext cx="3932237" cy="1600200"/>
+            <a:off x="518307" y="193146"/>
+            <a:ext cx="2426928" cy="676011"/>
           </a:xfrm>
         </p:spPr>
         <p:txBody>
           <a:bodyPr anchor="b"/>
           <a:lstStyle>
             <a:lvl1pPr>
-              <a:defRPr sz="3200"/>
+              <a:defRPr sz="1352"/>
             </a:lvl1pPr>
           </a:lstStyle>
           <a:p>
             <a:r>
-              <a:rPr lang="zh-CN" altLang="en-US"/>
+              <a:rPr lang="zh-CN" altLang="en-US" smtClean="0"/>
               <a:t>单击此处编辑母版标题样式</a:t>
             </a:r>
-          </a:p>
-        </p:txBody>
-      </p:sp>
-      <p:sp>
-        <p:nvSpPr>
-          <p:cNvPr id="3" name="图片占位符 2">
-            <a:extLst>
-              <a:ext uri="{FF2B5EF4-FFF2-40B4-BE49-F238E27FC236}">
-                <a16:creationId xmlns:a16="http://schemas.microsoft.com/office/drawing/2014/main" id="{DA41BACE-7C9A-4DA7-99AB-9A810116A713}"/>
-              </a:ext>
-            </a:extLst>
-          </p:cNvPr>
-          <p:cNvSpPr>
-            <a:spLocks noGrp="1"/>
+            <a:endParaRPr lang="en-US" dirty="0"/>
+          </a:p>
+        </p:txBody>
+      </p:sp>
+      <p:sp>
+        <p:nvSpPr>
+          <p:cNvPr id="3" name="Picture Placeholder 2"/>
+          <p:cNvSpPr>
+            <a:spLocks noGrp="1" noChangeAspect="1"/>
           </p:cNvSpPr>
           <p:nvPr>
             <p:ph type="pic" idx="1"/>
@@ -2520,64 +2694,62 @@
         </p:nvSpPr>
         <p:spPr>
           <a:xfrm>
-            <a:off x="5183188" y="987425"/>
-            <a:ext cx="6172200" cy="4873625"/>
+            <a:off x="3198999" y="417142"/>
+            <a:ext cx="3809405" cy="2058881"/>
           </a:xfrm>
         </p:spPr>
         <p:txBody>
-          <a:bodyPr/>
+          <a:bodyPr anchor="t"/>
           <a:lstStyle>
             <a:lvl1pPr marL="0" indent="0">
               <a:buNone/>
-              <a:defRPr sz="3200"/>
+              <a:defRPr sz="1352"/>
             </a:lvl1pPr>
-            <a:lvl2pPr marL="457200" indent="0">
-              <a:buNone/>
-              <a:defRPr sz="2800"/>
+            <a:lvl2pPr marL="193167" indent="0">
+              <a:buNone/>
+              <a:defRPr sz="1183"/>
             </a:lvl2pPr>
-            <a:lvl3pPr marL="914400" indent="0">
-              <a:buNone/>
-              <a:defRPr sz="2400"/>
+            <a:lvl3pPr marL="386334" indent="0">
+              <a:buNone/>
+              <a:defRPr sz="1014"/>
             </a:lvl3pPr>
-            <a:lvl4pPr marL="1371600" indent="0">
-              <a:buNone/>
-              <a:defRPr sz="2000"/>
+            <a:lvl4pPr marL="579501" indent="0">
+              <a:buNone/>
+              <a:defRPr sz="845"/>
             </a:lvl4pPr>
-            <a:lvl5pPr marL="1828800" indent="0">
-              <a:buNone/>
-              <a:defRPr sz="2000"/>
+            <a:lvl5pPr marL="772668" indent="0">
+              <a:buNone/>
+              <a:defRPr sz="845"/>
             </a:lvl5pPr>
-            <a:lvl6pPr marL="2286000" indent="0">
-              <a:buNone/>
-              <a:defRPr sz="2000"/>
+            <a:lvl6pPr marL="965835" indent="0">
+              <a:buNone/>
+              <a:defRPr sz="845"/>
             </a:lvl6pPr>
-            <a:lvl7pPr marL="2743200" indent="0">
-              <a:buNone/>
-              <a:defRPr sz="2000"/>
+            <a:lvl7pPr marL="1159002" indent="0">
+              <a:buNone/>
+              <a:defRPr sz="845"/>
             </a:lvl7pPr>
-            <a:lvl8pPr marL="3200400" indent="0">
-              <a:buNone/>
-              <a:defRPr sz="2000"/>
+            <a:lvl8pPr marL="1352169" indent="0">
+              <a:buNone/>
+              <a:defRPr sz="845"/>
             </a:lvl8pPr>
-            <a:lvl9pPr marL="3657600" indent="0">
-              <a:buNone/>
-              <a:defRPr sz="2000"/>
+            <a:lvl9pPr marL="1545336" indent="0">
+              <a:buNone/>
+              <a:defRPr sz="845"/>
             </a:lvl9pPr>
           </a:lstStyle>
           <a:p>
-            <a:endParaRPr lang="zh-CN" altLang="en-US"/>
-          </a:p>
-        </p:txBody>
-      </p:sp>
-      <p:sp>
-        <p:nvSpPr>
-          <p:cNvPr id="4" name="文本占位符 3">
-            <a:extLst>
-              <a:ext uri="{FF2B5EF4-FFF2-40B4-BE49-F238E27FC236}">
-                <a16:creationId xmlns:a16="http://schemas.microsoft.com/office/drawing/2014/main" id="{B25EACB8-3FBC-463D-A3FC-534B2EAAA95F}"/>
-              </a:ext>
-            </a:extLst>
-          </p:cNvPr>
+            <a:r>
+              <a:rPr lang="zh-CN" altLang="en-US" smtClean="0"/>
+              <a:t>单击图标添加图片</a:t>
+            </a:r>
+            <a:endParaRPr lang="en-US" dirty="0"/>
+          </a:p>
+        </p:txBody>
+      </p:sp>
+      <p:sp>
+        <p:nvSpPr>
+          <p:cNvPr id="4" name="Text Placeholder 3"/>
           <p:cNvSpPr>
             <a:spLocks noGrp="1"/>
           </p:cNvSpPr>
@@ -2587,8 +2759,8 @@
         </p:nvSpPr>
         <p:spPr>
           <a:xfrm>
-            <a:off x="839788" y="2057400"/>
-            <a:ext cx="3932237" cy="3811588"/>
+            <a:off x="518307" y="869156"/>
+            <a:ext cx="2426928" cy="1610220"/>
           </a:xfrm>
         </p:spPr>
         <p:txBody>
@@ -2596,45 +2768,45 @@
           <a:lstStyle>
             <a:lvl1pPr marL="0" indent="0">
               <a:buNone/>
-              <a:defRPr sz="1600"/>
+              <a:defRPr sz="676"/>
             </a:lvl1pPr>
-            <a:lvl2pPr marL="457200" indent="0">
-              <a:buNone/>
-              <a:defRPr sz="1400"/>
+            <a:lvl2pPr marL="193167" indent="0">
+              <a:buNone/>
+              <a:defRPr sz="592"/>
             </a:lvl2pPr>
-            <a:lvl3pPr marL="914400" indent="0">
-              <a:buNone/>
-              <a:defRPr sz="1200"/>
+            <a:lvl3pPr marL="386334" indent="0">
+              <a:buNone/>
+              <a:defRPr sz="507"/>
             </a:lvl3pPr>
-            <a:lvl4pPr marL="1371600" indent="0">
-              <a:buNone/>
-              <a:defRPr sz="1000"/>
+            <a:lvl4pPr marL="579501" indent="0">
+              <a:buNone/>
+              <a:defRPr sz="422"/>
             </a:lvl4pPr>
-            <a:lvl5pPr marL="1828800" indent="0">
-              <a:buNone/>
-              <a:defRPr sz="1000"/>
+            <a:lvl5pPr marL="772668" indent="0">
+              <a:buNone/>
+              <a:defRPr sz="422"/>
             </a:lvl5pPr>
-            <a:lvl6pPr marL="2286000" indent="0">
-              <a:buNone/>
-              <a:defRPr sz="1000"/>
+            <a:lvl6pPr marL="965835" indent="0">
+              <a:buNone/>
+              <a:defRPr sz="422"/>
             </a:lvl6pPr>
-            <a:lvl7pPr marL="2743200" indent="0">
-              <a:buNone/>
-              <a:defRPr sz="1000"/>
+            <a:lvl7pPr marL="1159002" indent="0">
+              <a:buNone/>
+              <a:defRPr sz="422"/>
             </a:lvl7pPr>
-            <a:lvl8pPr marL="3200400" indent="0">
-              <a:buNone/>
-              <a:defRPr sz="1000"/>
+            <a:lvl8pPr marL="1352169" indent="0">
+              <a:buNone/>
+              <a:defRPr sz="422"/>
             </a:lvl8pPr>
-            <a:lvl9pPr marL="3657600" indent="0">
-              <a:buNone/>
-              <a:defRPr sz="1000"/>
+            <a:lvl9pPr marL="1545336" indent="0">
+              <a:buNone/>
+              <a:defRPr sz="422"/>
             </a:lvl9pPr>
           </a:lstStyle>
           <a:p>
             <a:pPr lvl="0"/>
             <a:r>
-              <a:rPr lang="zh-CN" altLang="en-US"/>
+              <a:rPr lang="zh-CN" altLang="en-US" smtClean="0"/>
               <a:t>编辑母版文本样式</a:t>
             </a:r>
           </a:p>
@@ -2642,13 +2814,7 @@
       </p:sp>
       <p:sp>
         <p:nvSpPr>
-          <p:cNvPr id="5" name="日期占位符 4">
-            <a:extLst>
-              <a:ext uri="{FF2B5EF4-FFF2-40B4-BE49-F238E27FC236}">
-                <a16:creationId xmlns:a16="http://schemas.microsoft.com/office/drawing/2014/main" id="{707A6406-4356-427C-A818-3B0CB0305FD3}"/>
-              </a:ext>
-            </a:extLst>
-          </p:cNvPr>
+          <p:cNvPr id="5" name="Date Placeholder 4"/>
           <p:cNvSpPr>
             <a:spLocks noGrp="1"/>
           </p:cNvSpPr>
@@ -2663,7 +2829,7 @@
           <a:p>
             <a:fld id="{86716E46-D677-4FA8-974A-5B989B436838}" type="datetimeFigureOut">
               <a:rPr lang="zh-CN" altLang="en-US" smtClean="0"/>
-              <a:t>2018/8/17</a:t>
+              <a:t>2021/04/02</a:t>
             </a:fld>
             <a:endParaRPr lang="zh-CN" altLang="en-US"/>
           </a:p>
@@ -2671,13 +2837,7 @@
       </p:sp>
       <p:sp>
         <p:nvSpPr>
-          <p:cNvPr id="6" name="页脚占位符 5">
-            <a:extLst>
-              <a:ext uri="{FF2B5EF4-FFF2-40B4-BE49-F238E27FC236}">
-                <a16:creationId xmlns:a16="http://schemas.microsoft.com/office/drawing/2014/main" id="{69292A26-46A0-43E7-83CC-DFC63A87EA33}"/>
-              </a:ext>
-            </a:extLst>
-          </p:cNvPr>
+          <p:cNvPr id="6" name="Footer Placeholder 5"/>
           <p:cNvSpPr>
             <a:spLocks noGrp="1"/>
           </p:cNvSpPr>
@@ -2696,13 +2856,7 @@
       </p:sp>
       <p:sp>
         <p:nvSpPr>
-          <p:cNvPr id="7" name="灯片编号占位符 6">
-            <a:extLst>
-              <a:ext uri="{FF2B5EF4-FFF2-40B4-BE49-F238E27FC236}">
-                <a16:creationId xmlns:a16="http://schemas.microsoft.com/office/drawing/2014/main" id="{E9617A88-470D-4F26-828C-C803AF2509F8}"/>
-              </a:ext>
-            </a:extLst>
-          </p:cNvPr>
+          <p:cNvPr id="7" name="Slide Number Placeholder 6"/>
           <p:cNvSpPr>
             <a:spLocks noGrp="1"/>
           </p:cNvSpPr>
@@ -2726,7 +2880,7 @@
     </p:spTree>
     <p:extLst>
       <p:ext uri="{BB962C8B-B14F-4D97-AF65-F5344CB8AC3E}">
-        <p14:creationId xmlns:p14="http://schemas.microsoft.com/office/powerpoint/2010/main" val="1230540666"/>
+        <p14:creationId xmlns:p14="http://schemas.microsoft.com/office/powerpoint/2010/main" val="3276147452"/>
       </p:ext>
     </p:extLst>
   </p:cSld>
@@ -2760,13 +2914,7 @@
       </p:grpSpPr>
       <p:sp>
         <p:nvSpPr>
-          <p:cNvPr id="2" name="标题占位符 1">
-            <a:extLst>
-              <a:ext uri="{FF2B5EF4-FFF2-40B4-BE49-F238E27FC236}">
-                <a16:creationId xmlns:a16="http://schemas.microsoft.com/office/drawing/2014/main" id="{90D7B8A3-E6CB-458A-A165-296E43CE82DC}"/>
-              </a:ext>
-            </a:extLst>
-          </p:cNvPr>
+          <p:cNvPr id="2" name="Title Placeholder 1"/>
           <p:cNvSpPr>
             <a:spLocks noGrp="1"/>
           </p:cNvSpPr>
@@ -2776,8 +2924,8 @@
         </p:nvSpPr>
         <p:spPr>
           <a:xfrm>
-            <a:off x="838200" y="365125"/>
-            <a:ext cx="10515600" cy="1325563"/>
+            <a:off x="517327" y="154249"/>
+            <a:ext cx="6490097" cy="559989"/>
           </a:xfrm>
           <a:prstGeom prst="rect">
             <a:avLst/>
@@ -2790,21 +2938,16 @@
           <a:lstStyle/>
           <a:p>
             <a:r>
-              <a:rPr lang="zh-CN" altLang="en-US"/>
+              <a:rPr lang="zh-CN" altLang="en-US" smtClean="0"/>
               <a:t>单击此处编辑母版标题样式</a:t>
             </a:r>
-          </a:p>
-        </p:txBody>
-      </p:sp>
-      <p:sp>
-        <p:nvSpPr>
-          <p:cNvPr id="3" name="文本占位符 2">
-            <a:extLst>
-              <a:ext uri="{FF2B5EF4-FFF2-40B4-BE49-F238E27FC236}">
-                <a16:creationId xmlns:a16="http://schemas.microsoft.com/office/drawing/2014/main" id="{7193EFB4-0A88-46B3-847D-B3F2EB8F6570}"/>
-              </a:ext>
-            </a:extLst>
-          </p:cNvPr>
+            <a:endParaRPr lang="en-US" dirty="0"/>
+          </a:p>
+        </p:txBody>
+      </p:sp>
+      <p:sp>
+        <p:nvSpPr>
+          <p:cNvPr id="3" name="Text Placeholder 2"/>
           <p:cNvSpPr>
             <a:spLocks noGrp="1"/>
           </p:cNvSpPr>
@@ -2814,8 +2957,8 @@
         </p:nvSpPr>
         <p:spPr>
           <a:xfrm>
-            <a:off x="838200" y="1825625"/>
-            <a:ext cx="10515600" cy="4351338"/>
+            <a:off x="517327" y="771242"/>
+            <a:ext cx="6490097" cy="1838239"/>
           </a:xfrm>
           <a:prstGeom prst="rect">
             <a:avLst/>
@@ -2829,49 +2972,44 @@
           <a:p>
             <a:pPr lvl="0"/>
             <a:r>
-              <a:rPr lang="zh-CN" altLang="en-US"/>
+              <a:rPr lang="zh-CN" altLang="en-US" smtClean="0"/>
               <a:t>编辑母版文本样式</a:t>
             </a:r>
           </a:p>
           <a:p>
             <a:pPr lvl="1"/>
             <a:r>
-              <a:rPr lang="zh-CN" altLang="en-US"/>
+              <a:rPr lang="zh-CN" altLang="en-US" smtClean="0"/>
               <a:t>第二级</a:t>
             </a:r>
           </a:p>
           <a:p>
             <a:pPr lvl="2"/>
             <a:r>
-              <a:rPr lang="zh-CN" altLang="en-US"/>
+              <a:rPr lang="zh-CN" altLang="en-US" smtClean="0"/>
               <a:t>第三级</a:t>
             </a:r>
           </a:p>
           <a:p>
             <a:pPr lvl="3"/>
             <a:r>
-              <a:rPr lang="zh-CN" altLang="en-US"/>
+              <a:rPr lang="zh-CN" altLang="en-US" smtClean="0"/>
               <a:t>第四级</a:t>
             </a:r>
           </a:p>
           <a:p>
             <a:pPr lvl="4"/>
             <a:r>
-              <a:rPr lang="zh-CN" altLang="en-US"/>
+              <a:rPr lang="zh-CN" altLang="en-US" smtClean="0"/>
               <a:t>第五级</a:t>
             </a:r>
-          </a:p>
-        </p:txBody>
-      </p:sp>
-      <p:sp>
-        <p:nvSpPr>
-          <p:cNvPr id="4" name="日期占位符 3">
-            <a:extLst>
-              <a:ext uri="{FF2B5EF4-FFF2-40B4-BE49-F238E27FC236}">
-                <a16:creationId xmlns:a16="http://schemas.microsoft.com/office/drawing/2014/main" id="{AAAA5305-0690-4BCC-801C-58DB02B28FD3}"/>
-              </a:ext>
-            </a:extLst>
-          </p:cNvPr>
+            <a:endParaRPr lang="en-US" dirty="0"/>
+          </a:p>
+        </p:txBody>
+      </p:sp>
+      <p:sp>
+        <p:nvSpPr>
+          <p:cNvPr id="4" name="Date Placeholder 3"/>
           <p:cNvSpPr>
             <a:spLocks noGrp="1"/>
           </p:cNvSpPr>
@@ -2881,8 +3019,8 @@
         </p:nvSpPr>
         <p:spPr>
           <a:xfrm>
-            <a:off x="838200" y="6356350"/>
-            <a:ext cx="2743200" cy="365125"/>
+            <a:off x="517326" y="2685264"/>
+            <a:ext cx="1693069" cy="154248"/>
           </a:xfrm>
           <a:prstGeom prst="rect">
             <a:avLst/>
@@ -2892,7 +3030,7 @@
           <a:bodyPr vert="horz" lIns="91440" tIns="45720" rIns="91440" bIns="45720" rtlCol="0" anchor="ctr"/>
           <a:lstStyle>
             <a:lvl1pPr algn="l">
-              <a:defRPr sz="1200">
+              <a:defRPr sz="507">
                 <a:solidFill>
                   <a:schemeClr val="tx1">
                     <a:tint val="75000"/>
@@ -2904,7 +3042,7 @@
           <a:p>
             <a:fld id="{86716E46-D677-4FA8-974A-5B989B436838}" type="datetimeFigureOut">
               <a:rPr lang="zh-CN" altLang="en-US" smtClean="0"/>
-              <a:t>2018/8/17</a:t>
+              <a:t>2021/04/02</a:t>
             </a:fld>
             <a:endParaRPr lang="zh-CN" altLang="en-US"/>
           </a:p>
@@ -2912,13 +3050,7 @@
       </p:sp>
       <p:sp>
         <p:nvSpPr>
-          <p:cNvPr id="5" name="页脚占位符 4">
-            <a:extLst>
-              <a:ext uri="{FF2B5EF4-FFF2-40B4-BE49-F238E27FC236}">
-                <a16:creationId xmlns:a16="http://schemas.microsoft.com/office/drawing/2014/main" id="{527BCE8D-ED06-43F9-9050-7653C7116C39}"/>
-              </a:ext>
-            </a:extLst>
-          </p:cNvPr>
+          <p:cNvPr id="5" name="Footer Placeholder 4"/>
           <p:cNvSpPr>
             <a:spLocks noGrp="1"/>
           </p:cNvSpPr>
@@ -2928,8 +3060,8 @@
         </p:nvSpPr>
         <p:spPr>
           <a:xfrm>
-            <a:off x="4038600" y="6356350"/>
-            <a:ext cx="4114800" cy="365125"/>
+            <a:off x="2492574" y="2685264"/>
+            <a:ext cx="2539603" cy="154248"/>
           </a:xfrm>
           <a:prstGeom prst="rect">
             <a:avLst/>
@@ -2939,7 +3071,7 @@
           <a:bodyPr vert="horz" lIns="91440" tIns="45720" rIns="91440" bIns="45720" rtlCol="0" anchor="ctr"/>
           <a:lstStyle>
             <a:lvl1pPr algn="ctr">
-              <a:defRPr sz="1200">
+              <a:defRPr sz="507">
                 <a:solidFill>
                   <a:schemeClr val="tx1">
                     <a:tint val="75000"/>
@@ -2955,13 +3087,7 @@
       </p:sp>
       <p:sp>
         <p:nvSpPr>
-          <p:cNvPr id="6" name="灯片编号占位符 5">
-            <a:extLst>
-              <a:ext uri="{FF2B5EF4-FFF2-40B4-BE49-F238E27FC236}">
-                <a16:creationId xmlns:a16="http://schemas.microsoft.com/office/drawing/2014/main" id="{EA5226BF-64BC-4523-B867-DC7B10AE0829}"/>
-              </a:ext>
-            </a:extLst>
-          </p:cNvPr>
+          <p:cNvPr id="6" name="Slide Number Placeholder 5"/>
           <p:cNvSpPr>
             <a:spLocks noGrp="1"/>
           </p:cNvSpPr>
@@ -2971,8 +3097,8 @@
         </p:nvSpPr>
         <p:spPr>
           <a:xfrm>
-            <a:off x="8610600" y="6356350"/>
-            <a:ext cx="2743200" cy="365125"/>
+            <a:off x="5314355" y="2685264"/>
+            <a:ext cx="1693069" cy="154248"/>
           </a:xfrm>
           <a:prstGeom prst="rect">
             <a:avLst/>
@@ -2982,7 +3108,7 @@
           <a:bodyPr vert="horz" lIns="91440" tIns="45720" rIns="91440" bIns="45720" rtlCol="0" anchor="ctr"/>
           <a:lstStyle>
             <a:lvl1pPr algn="r">
-              <a:defRPr sz="1200">
+              <a:defRPr sz="507">
                 <a:solidFill>
                   <a:schemeClr val="tx1">
                     <a:tint val="75000"/>
@@ -3003,27 +3129,27 @@
     </p:spTree>
     <p:extLst>
       <p:ext uri="{BB962C8B-B14F-4D97-AF65-F5344CB8AC3E}">
-        <p14:creationId xmlns:p14="http://schemas.microsoft.com/office/powerpoint/2010/main" val="1356723479"/>
+        <p14:creationId xmlns:p14="http://schemas.microsoft.com/office/powerpoint/2010/main" val="688750701"/>
       </p:ext>
     </p:extLst>
   </p:cSld>
   <p:clrMap bg1="lt1" tx1="dk1" bg2="lt2" tx2="dk2" accent1="accent1" accent2="accent2" accent3="accent3" accent4="accent4" accent5="accent5" accent6="accent6" hlink="hlink" folHlink="folHlink"/>
   <p:sldLayoutIdLst>
-    <p:sldLayoutId id="2147483649" r:id="rId1"/>
-    <p:sldLayoutId id="2147483650" r:id="rId2"/>
-    <p:sldLayoutId id="2147483651" r:id="rId3"/>
-    <p:sldLayoutId id="2147483652" r:id="rId4"/>
-    <p:sldLayoutId id="2147483653" r:id="rId5"/>
-    <p:sldLayoutId id="2147483654" r:id="rId6"/>
-    <p:sldLayoutId id="2147483655" r:id="rId7"/>
-    <p:sldLayoutId id="2147483656" r:id="rId8"/>
-    <p:sldLayoutId id="2147483657" r:id="rId9"/>
-    <p:sldLayoutId id="2147483658" r:id="rId10"/>
-    <p:sldLayoutId id="2147483659" r:id="rId11"/>
+    <p:sldLayoutId id="2147483685" r:id="rId1"/>
+    <p:sldLayoutId id="2147483686" r:id="rId2"/>
+    <p:sldLayoutId id="2147483687" r:id="rId3"/>
+    <p:sldLayoutId id="2147483688" r:id="rId4"/>
+    <p:sldLayoutId id="2147483689" r:id="rId5"/>
+    <p:sldLayoutId id="2147483690" r:id="rId6"/>
+    <p:sldLayoutId id="2147483691" r:id="rId7"/>
+    <p:sldLayoutId id="2147483692" r:id="rId8"/>
+    <p:sldLayoutId id="2147483693" r:id="rId9"/>
+    <p:sldLayoutId id="2147483694" r:id="rId10"/>
+    <p:sldLayoutId id="2147483695" r:id="rId11"/>
   </p:sldLayoutIdLst>
   <p:txStyles>
     <p:titleStyle>
-      <a:lvl1pPr algn="l" defTabSz="914400" rtl="0" eaLnBrk="1" latinLnBrk="0" hangingPunct="1">
+      <a:lvl1pPr algn="l" defTabSz="386334" rtl="0" eaLnBrk="1" latinLnBrk="0" hangingPunct="1">
         <a:lnSpc>
           <a:spcPct val="90000"/>
         </a:lnSpc>
@@ -3031,7 +3157,7 @@
           <a:spcPct val="0"/>
         </a:spcBef>
         <a:buNone/>
-        <a:defRPr sz="4400" kern="1200">
+        <a:defRPr sz="1859" kern="1200">
           <a:solidFill>
             <a:schemeClr val="tx1"/>
           </a:solidFill>
@@ -3042,16 +3168,16 @@
       </a:lvl1pPr>
     </p:titleStyle>
     <p:bodyStyle>
-      <a:lvl1pPr marL="228600" indent="-228600" algn="l" defTabSz="914400" rtl="0" eaLnBrk="1" latinLnBrk="0" hangingPunct="1">
+      <a:lvl1pPr marL="96584" indent="-96584" algn="l" defTabSz="386334" rtl="0" eaLnBrk="1" latinLnBrk="0" hangingPunct="1">
         <a:lnSpc>
           <a:spcPct val="90000"/>
         </a:lnSpc>
         <a:spcBef>
-          <a:spcPts val="1000"/>
+          <a:spcPts val="422"/>
         </a:spcBef>
         <a:buFont typeface="Arial" panose="020B0604020202020204" pitchFamily="34" charset="0"/>
         <a:buChar char="•"/>
-        <a:defRPr sz="2800" kern="1200">
+        <a:defRPr sz="1183" kern="1200">
           <a:solidFill>
             <a:schemeClr val="tx1"/>
           </a:solidFill>
@@ -3060,16 +3186,16 @@
           <a:cs typeface="+mn-cs"/>
         </a:defRPr>
       </a:lvl1pPr>
-      <a:lvl2pPr marL="685800" indent="-228600" algn="l" defTabSz="914400" rtl="0" eaLnBrk="1" latinLnBrk="0" hangingPunct="1">
+      <a:lvl2pPr marL="289751" indent="-96584" algn="l" defTabSz="386334" rtl="0" eaLnBrk="1" latinLnBrk="0" hangingPunct="1">
         <a:lnSpc>
           <a:spcPct val="90000"/>
         </a:lnSpc>
         <a:spcBef>
-          <a:spcPts val="500"/>
+          <a:spcPts val="211"/>
         </a:spcBef>
         <a:buFont typeface="Arial" panose="020B0604020202020204" pitchFamily="34" charset="0"/>
         <a:buChar char="•"/>
-        <a:defRPr sz="2400" kern="1200">
+        <a:defRPr sz="1014" kern="1200">
           <a:solidFill>
             <a:schemeClr val="tx1"/>
           </a:solidFill>
@@ -3078,16 +3204,16 @@
           <a:cs typeface="+mn-cs"/>
         </a:defRPr>
       </a:lvl2pPr>
-      <a:lvl3pPr marL="1143000" indent="-228600" algn="l" defTabSz="914400" rtl="0" eaLnBrk="1" latinLnBrk="0" hangingPunct="1">
+      <a:lvl3pPr marL="482918" indent="-96584" algn="l" defTabSz="386334" rtl="0" eaLnBrk="1" latinLnBrk="0" hangingPunct="1">
         <a:lnSpc>
           <a:spcPct val="90000"/>
         </a:lnSpc>
         <a:spcBef>
-          <a:spcPts val="500"/>
+          <a:spcPts val="211"/>
         </a:spcBef>
         <a:buFont typeface="Arial" panose="020B0604020202020204" pitchFamily="34" charset="0"/>
         <a:buChar char="•"/>
-        <a:defRPr sz="2000" kern="1200">
+        <a:defRPr sz="845" kern="1200">
           <a:solidFill>
             <a:schemeClr val="tx1"/>
           </a:solidFill>
@@ -3096,16 +3222,16 @@
           <a:cs typeface="+mn-cs"/>
         </a:defRPr>
       </a:lvl3pPr>
-      <a:lvl4pPr marL="1600200" indent="-228600" algn="l" defTabSz="914400" rtl="0" eaLnBrk="1" latinLnBrk="0" hangingPunct="1">
+      <a:lvl4pPr marL="676085" indent="-96584" algn="l" defTabSz="386334" rtl="0" eaLnBrk="1" latinLnBrk="0" hangingPunct="1">
         <a:lnSpc>
           <a:spcPct val="90000"/>
         </a:lnSpc>
         <a:spcBef>
-          <a:spcPts val="500"/>
+          <a:spcPts val="211"/>
         </a:spcBef>
         <a:buFont typeface="Arial" panose="020B0604020202020204" pitchFamily="34" charset="0"/>
         <a:buChar char="•"/>
-        <a:defRPr sz="1800" kern="1200">
+        <a:defRPr sz="761" kern="1200">
           <a:solidFill>
             <a:schemeClr val="tx1"/>
           </a:solidFill>
@@ -3114,16 +3240,16 @@
           <a:cs typeface="+mn-cs"/>
         </a:defRPr>
       </a:lvl4pPr>
-      <a:lvl5pPr marL="2057400" indent="-228600" algn="l" defTabSz="914400" rtl="0" eaLnBrk="1" latinLnBrk="0" hangingPunct="1">
+      <a:lvl5pPr marL="869252" indent="-96584" algn="l" defTabSz="386334" rtl="0" eaLnBrk="1" latinLnBrk="0" hangingPunct="1">
         <a:lnSpc>
           <a:spcPct val="90000"/>
         </a:lnSpc>
         <a:spcBef>
-          <a:spcPts val="500"/>
+          <a:spcPts val="211"/>
         </a:spcBef>
         <a:buFont typeface="Arial" panose="020B0604020202020204" pitchFamily="34" charset="0"/>
         <a:buChar char="•"/>
-        <a:defRPr sz="1800" kern="1200">
+        <a:defRPr sz="761" kern="1200">
           <a:solidFill>
             <a:schemeClr val="tx1"/>
           </a:solidFill>
@@ -3132,16 +3258,16 @@
           <a:cs typeface="+mn-cs"/>
         </a:defRPr>
       </a:lvl5pPr>
-      <a:lvl6pPr marL="2514600" indent="-228600" algn="l" defTabSz="914400" rtl="0" eaLnBrk="1" latinLnBrk="0" hangingPunct="1">
+      <a:lvl6pPr marL="1062419" indent="-96584" algn="l" defTabSz="386334" rtl="0" eaLnBrk="1" latinLnBrk="0" hangingPunct="1">
         <a:lnSpc>
           <a:spcPct val="90000"/>
         </a:lnSpc>
         <a:spcBef>
-          <a:spcPts val="500"/>
+          <a:spcPts val="211"/>
         </a:spcBef>
         <a:buFont typeface="Arial" panose="020B0604020202020204" pitchFamily="34" charset="0"/>
         <a:buChar char="•"/>
-        <a:defRPr sz="1800" kern="1200">
+        <a:defRPr sz="761" kern="1200">
           <a:solidFill>
             <a:schemeClr val="tx1"/>
           </a:solidFill>
@@ -3150,16 +3276,16 @@
           <a:cs typeface="+mn-cs"/>
         </a:defRPr>
       </a:lvl6pPr>
-      <a:lvl7pPr marL="2971800" indent="-228600" algn="l" defTabSz="914400" rtl="0" eaLnBrk="1" latinLnBrk="0" hangingPunct="1">
+      <a:lvl7pPr marL="1255586" indent="-96584" algn="l" defTabSz="386334" rtl="0" eaLnBrk="1" latinLnBrk="0" hangingPunct="1">
         <a:lnSpc>
           <a:spcPct val="90000"/>
         </a:lnSpc>
         <a:spcBef>
-          <a:spcPts val="500"/>
+          <a:spcPts val="211"/>
         </a:spcBef>
         <a:buFont typeface="Arial" panose="020B0604020202020204" pitchFamily="34" charset="0"/>
         <a:buChar char="•"/>
-        <a:defRPr sz="1800" kern="1200">
+        <a:defRPr sz="761" kern="1200">
           <a:solidFill>
             <a:schemeClr val="tx1"/>
           </a:solidFill>
@@ -3168,16 +3294,16 @@
           <a:cs typeface="+mn-cs"/>
         </a:defRPr>
       </a:lvl7pPr>
-      <a:lvl8pPr marL="3429000" indent="-228600" algn="l" defTabSz="914400" rtl="0" eaLnBrk="1" latinLnBrk="0" hangingPunct="1">
+      <a:lvl8pPr marL="1448753" indent="-96584" algn="l" defTabSz="386334" rtl="0" eaLnBrk="1" latinLnBrk="0" hangingPunct="1">
         <a:lnSpc>
           <a:spcPct val="90000"/>
         </a:lnSpc>
         <a:spcBef>
-          <a:spcPts val="500"/>
+          <a:spcPts val="211"/>
         </a:spcBef>
         <a:buFont typeface="Arial" panose="020B0604020202020204" pitchFamily="34" charset="0"/>
         <a:buChar char="•"/>
-        <a:defRPr sz="1800" kern="1200">
+        <a:defRPr sz="761" kern="1200">
           <a:solidFill>
             <a:schemeClr val="tx1"/>
           </a:solidFill>
@@ -3186,16 +3312,16 @@
           <a:cs typeface="+mn-cs"/>
         </a:defRPr>
       </a:lvl8pPr>
-      <a:lvl9pPr marL="3886200" indent="-228600" algn="l" defTabSz="914400" rtl="0" eaLnBrk="1" latinLnBrk="0" hangingPunct="1">
+      <a:lvl9pPr marL="1641920" indent="-96584" algn="l" defTabSz="386334" rtl="0" eaLnBrk="1" latinLnBrk="0" hangingPunct="1">
         <a:lnSpc>
           <a:spcPct val="90000"/>
         </a:lnSpc>
         <a:spcBef>
-          <a:spcPts val="500"/>
+          <a:spcPts val="211"/>
         </a:spcBef>
         <a:buFont typeface="Arial" panose="020B0604020202020204" pitchFamily="34" charset="0"/>
         <a:buChar char="•"/>
-        <a:defRPr sz="1800" kern="1200">
+        <a:defRPr sz="761" kern="1200">
           <a:solidFill>
             <a:schemeClr val="tx1"/>
           </a:solidFill>
@@ -3207,10 +3333,10 @@
     </p:bodyStyle>
     <p:otherStyle>
       <a:defPPr>
-        <a:defRPr lang="zh-CN"/>
+        <a:defRPr lang="en-US"/>
       </a:defPPr>
-      <a:lvl1pPr marL="0" algn="l" defTabSz="914400" rtl="0" eaLnBrk="1" latinLnBrk="0" hangingPunct="1">
-        <a:defRPr sz="1800" kern="1200">
+      <a:lvl1pPr marL="0" algn="l" defTabSz="386334" rtl="0" eaLnBrk="1" latinLnBrk="0" hangingPunct="1">
+        <a:defRPr sz="761" kern="1200">
           <a:solidFill>
             <a:schemeClr val="tx1"/>
           </a:solidFill>
@@ -3219,8 +3345,8 @@
           <a:cs typeface="+mn-cs"/>
         </a:defRPr>
       </a:lvl1pPr>
-      <a:lvl2pPr marL="457200" algn="l" defTabSz="914400" rtl="0" eaLnBrk="1" latinLnBrk="0" hangingPunct="1">
-        <a:defRPr sz="1800" kern="1200">
+      <a:lvl2pPr marL="193167" algn="l" defTabSz="386334" rtl="0" eaLnBrk="1" latinLnBrk="0" hangingPunct="1">
+        <a:defRPr sz="761" kern="1200">
           <a:solidFill>
             <a:schemeClr val="tx1"/>
           </a:solidFill>
@@ -3229,8 +3355,8 @@
           <a:cs typeface="+mn-cs"/>
         </a:defRPr>
       </a:lvl2pPr>
-      <a:lvl3pPr marL="914400" algn="l" defTabSz="914400" rtl="0" eaLnBrk="1" latinLnBrk="0" hangingPunct="1">
-        <a:defRPr sz="1800" kern="1200">
+      <a:lvl3pPr marL="386334" algn="l" defTabSz="386334" rtl="0" eaLnBrk="1" latinLnBrk="0" hangingPunct="1">
+        <a:defRPr sz="761" kern="1200">
           <a:solidFill>
             <a:schemeClr val="tx1"/>
           </a:solidFill>
@@ -3239,8 +3365,8 @@
           <a:cs typeface="+mn-cs"/>
         </a:defRPr>
       </a:lvl3pPr>
-      <a:lvl4pPr marL="1371600" algn="l" defTabSz="914400" rtl="0" eaLnBrk="1" latinLnBrk="0" hangingPunct="1">
-        <a:defRPr sz="1800" kern="1200">
+      <a:lvl4pPr marL="579501" algn="l" defTabSz="386334" rtl="0" eaLnBrk="1" latinLnBrk="0" hangingPunct="1">
+        <a:defRPr sz="761" kern="1200">
           <a:solidFill>
             <a:schemeClr val="tx1"/>
           </a:solidFill>
@@ -3249,8 +3375,8 @@
           <a:cs typeface="+mn-cs"/>
         </a:defRPr>
       </a:lvl4pPr>
-      <a:lvl5pPr marL="1828800" algn="l" defTabSz="914400" rtl="0" eaLnBrk="1" latinLnBrk="0" hangingPunct="1">
-        <a:defRPr sz="1800" kern="1200">
+      <a:lvl5pPr marL="772668" algn="l" defTabSz="386334" rtl="0" eaLnBrk="1" latinLnBrk="0" hangingPunct="1">
+        <a:defRPr sz="761" kern="1200">
           <a:solidFill>
             <a:schemeClr val="tx1"/>
           </a:solidFill>
@@ -3259,8 +3385,8 @@
           <a:cs typeface="+mn-cs"/>
         </a:defRPr>
       </a:lvl5pPr>
-      <a:lvl6pPr marL="2286000" algn="l" defTabSz="914400" rtl="0" eaLnBrk="1" latinLnBrk="0" hangingPunct="1">
-        <a:defRPr sz="1800" kern="1200">
+      <a:lvl6pPr marL="965835" algn="l" defTabSz="386334" rtl="0" eaLnBrk="1" latinLnBrk="0" hangingPunct="1">
+        <a:defRPr sz="761" kern="1200">
           <a:solidFill>
             <a:schemeClr val="tx1"/>
           </a:solidFill>
@@ -3269,8 +3395,8 @@
           <a:cs typeface="+mn-cs"/>
         </a:defRPr>
       </a:lvl6pPr>
-      <a:lvl7pPr marL="2743200" algn="l" defTabSz="914400" rtl="0" eaLnBrk="1" latinLnBrk="0" hangingPunct="1">
-        <a:defRPr sz="1800" kern="1200">
+      <a:lvl7pPr marL="1159002" algn="l" defTabSz="386334" rtl="0" eaLnBrk="1" latinLnBrk="0" hangingPunct="1">
+        <a:defRPr sz="761" kern="1200">
           <a:solidFill>
             <a:schemeClr val="tx1"/>
           </a:solidFill>
@@ -3279,8 +3405,8 @@
           <a:cs typeface="+mn-cs"/>
         </a:defRPr>
       </a:lvl7pPr>
-      <a:lvl8pPr marL="3200400" algn="l" defTabSz="914400" rtl="0" eaLnBrk="1" latinLnBrk="0" hangingPunct="1">
-        <a:defRPr sz="1800" kern="1200">
+      <a:lvl8pPr marL="1352169" algn="l" defTabSz="386334" rtl="0" eaLnBrk="1" latinLnBrk="0" hangingPunct="1">
+        <a:defRPr sz="761" kern="1200">
           <a:solidFill>
             <a:schemeClr val="tx1"/>
           </a:solidFill>
@@ -3289,8 +3415,8 @@
           <a:cs typeface="+mn-cs"/>
         </a:defRPr>
       </a:lvl8pPr>
-      <a:lvl9pPr marL="3657600" algn="l" defTabSz="914400" rtl="0" eaLnBrk="1" latinLnBrk="0" hangingPunct="1">
-        <a:defRPr sz="1800" kern="1200">
+      <a:lvl9pPr marL="1545336" algn="l" defTabSz="386334" rtl="0" eaLnBrk="1" latinLnBrk="0" hangingPunct="1">
+        <a:defRPr sz="761" kern="1200">
           <a:solidFill>
             <a:schemeClr val="tx1"/>
           </a:solidFill>
@@ -3335,14 +3461,14 @@
         </p:nvSpPr>
         <p:spPr>
           <a:xfrm>
-            <a:off x="0" y="2171700"/>
-            <a:ext cx="12192000" cy="2933700"/>
+            <a:off x="0" y="0"/>
+            <a:ext cx="6407150" cy="1056999"/>
           </a:xfrm>
           <a:prstGeom prst="rect">
             <a:avLst/>
           </a:prstGeom>
           <a:blipFill>
-            <a:blip r:embed="rId2"/>
+            <a:blip r:embed="rId3"/>
             <a:tile tx="0" ty="0" sx="100000" sy="100000" flip="none" algn="tl"/>
           </a:blipFill>
           <a:ln>
@@ -3370,7 +3496,7 @@
           <a:lstStyle/>
           <a:p>
             <a:pPr algn="ctr"/>
-            <a:endParaRPr lang="zh-CN" altLang="en-US" dirty="0"/>
+            <a:endParaRPr lang="zh-CN" altLang="en-US" sz="5284" dirty="0"/>
           </a:p>
         </p:txBody>
       </p:sp>
@@ -3388,8 +3514,8 @@
         </p:nvGrpSpPr>
         <p:grpSpPr>
           <a:xfrm>
-            <a:off x="8696926" y="2415652"/>
-            <a:ext cx="3313106" cy="649595"/>
+            <a:off x="2543447" y="72950"/>
+            <a:ext cx="720000" cy="126000"/>
             <a:chOff x="7596384" y="2235770"/>
             <a:chExt cx="3581393" cy="754226"/>
           </a:xfrm>
@@ -3409,7 +3535,7 @@
             <p:nvPr/>
           </p:nvPicPr>
           <p:blipFill>
-            <a:blip r:embed="rId3">
+            <a:blip r:embed="rId4" cstate="hqprint">
               <a:extLst>
                 <a:ext uri="{28A0092B-C50C-407E-A947-70E740481C1C}">
                   <a14:useLocalDpi xmlns:a14="http://schemas.microsoft.com/office/drawing/2010/main" val="0"/>
@@ -3456,7 +3582,7 @@
             <p:nvPr/>
           </p:nvPicPr>
           <p:blipFill>
-            <a:blip r:embed="rId4">
+            <a:blip r:embed="rId5">
               <a:clrChange>
                 <a:clrFrom>
                   <a:srgbClr val="000000"/>
@@ -3497,7 +3623,7 @@
             <p:nvPr/>
           </p:nvPicPr>
           <p:blipFill>
-            <a:blip r:embed="rId5">
+            <a:blip r:embed="rId6">
               <a:clrChange>
                 <a:clrFrom>
                   <a:srgbClr val="000000"/>
@@ -3538,7 +3664,7 @@
             <p:nvPr/>
           </p:nvPicPr>
           <p:blipFill>
-            <a:blip r:embed="rId6">
+            <a:blip r:embed="rId7">
               <a:clrChange>
                 <a:clrFrom>
                   <a:srgbClr val="000000"/>
@@ -3579,8 +3705,8 @@
         </p:nvGrpSpPr>
         <p:grpSpPr>
           <a:xfrm>
-            <a:off x="8729059" y="3103357"/>
-            <a:ext cx="3281815" cy="802073"/>
+            <a:off x="2547030" y="239519"/>
+            <a:ext cx="720000" cy="126000"/>
             <a:chOff x="7672992" y="3117211"/>
             <a:chExt cx="3547568" cy="931264"/>
           </a:xfrm>
@@ -3600,7 +3726,7 @@
             <p:nvPr/>
           </p:nvPicPr>
           <p:blipFill rotWithShape="1">
-            <a:blip r:embed="rId7">
+            <a:blip r:embed="rId8">
               <a:clrChange>
                 <a:clrFrom>
                   <a:srgbClr val="FCFEFC"/>
@@ -3640,7 +3766,7 @@
             <p:nvPr/>
           </p:nvPicPr>
           <p:blipFill>
-            <a:blip r:embed="rId8">
+            <a:blip r:embed="rId9">
               <a:clrChange>
                 <a:clrFrom>
                   <a:srgbClr val="FFFFFF"/>
@@ -3681,7 +3807,7 @@
             <p:nvPr/>
           </p:nvPicPr>
           <p:blipFill>
-            <a:blip r:embed="rId9">
+            <a:blip r:embed="rId10">
               <a:clrChange>
                 <a:clrFrom>
                   <a:srgbClr val="FFFFFF"/>
@@ -3722,7 +3848,7 @@
             <p:nvPr/>
           </p:nvPicPr>
           <p:blipFill rotWithShape="1">
-            <a:blip r:embed="rId10">
+            <a:blip r:embed="rId11">
               <a:clrChange>
                 <a:clrFrom>
                   <a:srgbClr val="FFFFFF"/>
@@ -3762,8 +3888,8 @@
         </p:nvGrpSpPr>
         <p:grpSpPr>
           <a:xfrm>
-            <a:off x="9216741" y="3979093"/>
-            <a:ext cx="2306451" cy="692602"/>
+            <a:off x="2637030" y="423856"/>
+            <a:ext cx="540000" cy="126000"/>
             <a:chOff x="7798803" y="4196874"/>
             <a:chExt cx="2493222" cy="804160"/>
           </a:xfrm>
@@ -3783,7 +3909,7 @@
             <p:nvPr/>
           </p:nvPicPr>
           <p:blipFill rotWithShape="1">
-            <a:blip r:embed="rId11">
+            <a:blip r:embed="rId12">
               <a:clrChange>
                 <a:clrFrom>
                   <a:srgbClr val="FFFFFF"/>
@@ -3823,7 +3949,7 @@
             <p:nvPr/>
           </p:nvPicPr>
           <p:blipFill>
-            <a:blip r:embed="rId12">
+            <a:blip r:embed="rId13">
               <a:clrChange>
                 <a:clrFrom>
                   <a:srgbClr val="FFFFFF"/>
@@ -3864,7 +3990,7 @@
             <p:nvPr/>
           </p:nvPicPr>
           <p:blipFill>
-            <a:blip r:embed="rId13">
+            <a:blip r:embed="rId14">
               <a:clrChange>
                 <a:clrFrom>
                   <a:srgbClr val="000000"/>
@@ -3891,79 +4017,6 @@
           </p:spPr>
         </p:pic>
       </p:grpSp>
-      <p:sp>
-        <p:nvSpPr>
-          <p:cNvPr id="2" name="文本框 1">
-            <a:extLst>
-              <a:ext uri="{FF2B5EF4-FFF2-40B4-BE49-F238E27FC236}">
-                <a16:creationId xmlns:a16="http://schemas.microsoft.com/office/drawing/2014/main" id="{3F9CD098-38D8-4F28-85F9-84E187F6F770}"/>
-              </a:ext>
-            </a:extLst>
-          </p:cNvPr>
-          <p:cNvSpPr txBox="1"/>
-          <p:nvPr/>
-        </p:nvSpPr>
-        <p:spPr>
-          <a:xfrm>
-            <a:off x="0" y="5580185"/>
-            <a:ext cx="12192000" cy="830997"/>
-          </a:xfrm>
-          <a:prstGeom prst="rect">
-            <a:avLst/>
-          </a:prstGeom>
-          <a:noFill/>
-        </p:spPr>
-        <p:txBody>
-          <a:bodyPr wrap="square" rtlCol="0">
-            <a:spAutoFit/>
-          </a:bodyPr>
-          <a:lstStyle/>
-          <a:p>
-            <a:pPr algn="ctr"/>
-            <a:r>
-              <a:rPr lang="zh-CN" altLang="en-US" sz="2400" dirty="0"/>
-              <a:t>（在使用“画图”打开</a:t>
-            </a:r>
-            <a:r>
-              <a:rPr lang="en-US" altLang="zh-CN" sz="2400" dirty="0"/>
-              <a:t>banner110.jpg</a:t>
-            </a:r>
-            <a:r>
-              <a:rPr lang="zh-CN" altLang="en-US" sz="2400" dirty="0"/>
-              <a:t>文件，剪切和调整长宽）</a:t>
-            </a:r>
-            <a:endParaRPr lang="en-US" altLang="zh-CN" sz="2400" dirty="0"/>
-          </a:p>
-          <a:p>
-            <a:pPr algn="ctr"/>
-            <a:r>
-              <a:rPr lang="en-US" altLang="zh-CN" sz="2400" dirty="0">
-                <a:solidFill>
-                  <a:srgbClr val="FF0000"/>
-                </a:solidFill>
-              </a:rPr>
-              <a:t>1000*200 </a:t>
-            </a:r>
-            <a:r>
-              <a:rPr lang="zh-CN" altLang="en-US" sz="2400" dirty="0">
-                <a:solidFill>
-                  <a:srgbClr val="FF0000"/>
-                </a:solidFill>
-              </a:rPr>
-              <a:t>像素 </a:t>
-            </a:r>
-            <a:r>
-              <a:rPr lang="zh-CN" altLang="en-US" sz="2400" dirty="0"/>
-              <a:t>→ 适合个人网站的</a:t>
-            </a:r>
-            <a:r>
-              <a:rPr lang="en-US" altLang="zh-CN" sz="2400" dirty="0"/>
-              <a:t>banner</a:t>
-            </a:r>
-            <a:endParaRPr lang="zh-CN" altLang="en-US" sz="2400" dirty="0"/>
-          </a:p>
-        </p:txBody>
-      </p:sp>
     </p:spTree>
     <p:extLst>
       <p:ext uri="{BB962C8B-B14F-4D97-AF65-F5344CB8AC3E}">
@@ -3980,6 +4033,267 @@
 <file path=ppt/theme/theme1.xml><?xml version="1.0" encoding="utf-8"?>
 <a:theme xmlns:a="http://schemas.openxmlformats.org/drawingml/2006/main" name="Office 主题​​">
   <a:themeElements>
+    <a:clrScheme name="Office 主题​​">
+      <a:dk1>
+        <a:sysClr val="windowText" lastClr="000000"/>
+      </a:dk1>
+      <a:lt1>
+        <a:sysClr val="window" lastClr="FFFFFF"/>
+      </a:lt1>
+      <a:dk2>
+        <a:srgbClr val="44546A"/>
+      </a:dk2>
+      <a:lt2>
+        <a:srgbClr val="E7E6E6"/>
+      </a:lt2>
+      <a:accent1>
+        <a:srgbClr val="5B9BD5"/>
+      </a:accent1>
+      <a:accent2>
+        <a:srgbClr val="ED7D31"/>
+      </a:accent2>
+      <a:accent3>
+        <a:srgbClr val="A5A5A5"/>
+      </a:accent3>
+      <a:accent4>
+        <a:srgbClr val="FFC000"/>
+      </a:accent4>
+      <a:accent5>
+        <a:srgbClr val="4472C4"/>
+      </a:accent5>
+      <a:accent6>
+        <a:srgbClr val="70AD47"/>
+      </a:accent6>
+      <a:hlink>
+        <a:srgbClr val="0563C1"/>
+      </a:hlink>
+      <a:folHlink>
+        <a:srgbClr val="954F72"/>
+      </a:folHlink>
+    </a:clrScheme>
+    <a:fontScheme name="Office 主题​​">
+      <a:majorFont>
+        <a:latin typeface="Calibri Light" panose="020F0302020204030204"/>
+        <a:ea typeface=""/>
+        <a:cs typeface=""/>
+        <a:font script="Jpan" typeface="游ゴシック Light"/>
+        <a:font script="Hang" typeface="맑은 고딕"/>
+        <a:font script="Hans" typeface="等线 Light"/>
+        <a:font script="Hant" typeface="新細明體"/>
+        <a:font script="Arab" typeface="Times New Roman"/>
+        <a:font script="Hebr" typeface="Times New Roman"/>
+        <a:font script="Thai" typeface="Angsana New"/>
+        <a:font script="Ethi" typeface="Nyala"/>
+        <a:font script="Beng" typeface="Vrinda"/>
+        <a:font script="Gujr" typeface="Shruti"/>
+        <a:font script="Khmr" typeface="MoolBoran"/>
+        <a:font script="Knda" typeface="Tunga"/>
+        <a:font script="Guru" typeface="Raavi"/>
+        <a:font script="Cans" typeface="Euphemia"/>
+        <a:font script="Cher" typeface="Plantagenet Cherokee"/>
+        <a:font script="Yiii" typeface="Microsoft Yi Baiti"/>
+        <a:font script="Tibt" typeface="Microsoft Himalaya"/>
+        <a:font script="Thaa" typeface="MV Boli"/>
+        <a:font script="Deva" typeface="Mangal"/>
+        <a:font script="Telu" typeface="Gautami"/>
+        <a:font script="Taml" typeface="Latha"/>
+        <a:font script="Syrc" typeface="Estrangelo Edessa"/>
+        <a:font script="Orya" typeface="Kalinga"/>
+        <a:font script="Mlym" typeface="Kartika"/>
+        <a:font script="Laoo" typeface="DokChampa"/>
+        <a:font script="Sinh" typeface="Iskoola Pota"/>
+        <a:font script="Mong" typeface="Mongolian Baiti"/>
+        <a:font script="Viet" typeface="Times New Roman"/>
+        <a:font script="Uigh" typeface="Microsoft Uighur"/>
+        <a:font script="Geor" typeface="Sylfaen"/>
+      </a:majorFont>
+      <a:minorFont>
+        <a:latin typeface="Calibri" panose="020F0502020204030204"/>
+        <a:ea typeface=""/>
+        <a:cs typeface=""/>
+        <a:font script="Jpan" typeface="游ゴシック"/>
+        <a:font script="Hang" typeface="맑은 고딕"/>
+        <a:font script="Hans" typeface="等线"/>
+        <a:font script="Hant" typeface="新細明體"/>
+        <a:font script="Arab" typeface="Arial"/>
+        <a:font script="Hebr" typeface="Arial"/>
+        <a:font script="Thai" typeface="Cordia New"/>
+        <a:font script="Ethi" typeface="Nyala"/>
+        <a:font script="Beng" typeface="Vrinda"/>
+        <a:font script="Gujr" typeface="Shruti"/>
+        <a:font script="Khmr" typeface="DaunPenh"/>
+        <a:font script="Knda" typeface="Tunga"/>
+        <a:font script="Guru" typeface="Raavi"/>
+        <a:font script="Cans" typeface="Euphemia"/>
+        <a:font script="Cher" typeface="Plantagenet Cherokee"/>
+        <a:font script="Yiii" typeface="Microsoft Yi Baiti"/>
+        <a:font script="Tibt" typeface="Microsoft Himalaya"/>
+        <a:font script="Thaa" typeface="MV Boli"/>
+        <a:font script="Deva" typeface="Mangal"/>
+        <a:font script="Telu" typeface="Gautami"/>
+        <a:font script="Taml" typeface="Latha"/>
+        <a:font script="Syrc" typeface="Estrangelo Edessa"/>
+        <a:font script="Orya" typeface="Kalinga"/>
+        <a:font script="Mlym" typeface="Kartika"/>
+        <a:font script="Laoo" typeface="DokChampa"/>
+        <a:font script="Sinh" typeface="Iskoola Pota"/>
+        <a:font script="Mong" typeface="Mongolian Baiti"/>
+        <a:font script="Viet" typeface="Arial"/>
+        <a:font script="Uigh" typeface="Microsoft Uighur"/>
+        <a:font script="Geor" typeface="Sylfaen"/>
+      </a:minorFont>
+    </a:fontScheme>
+    <a:fmtScheme name="Office 主题​​">
+      <a:fillStyleLst>
+        <a:solidFill>
+          <a:schemeClr val="phClr"/>
+        </a:solidFill>
+        <a:gradFill rotWithShape="1">
+          <a:gsLst>
+            <a:gs pos="0">
+              <a:schemeClr val="phClr">
+                <a:lumMod val="110000"/>
+                <a:satMod val="105000"/>
+                <a:tint val="67000"/>
+              </a:schemeClr>
+            </a:gs>
+            <a:gs pos="50000">
+              <a:schemeClr val="phClr">
+                <a:lumMod val="105000"/>
+                <a:satMod val="103000"/>
+                <a:tint val="73000"/>
+              </a:schemeClr>
+            </a:gs>
+            <a:gs pos="100000">
+              <a:schemeClr val="phClr">
+                <a:lumMod val="105000"/>
+                <a:satMod val="109000"/>
+                <a:tint val="81000"/>
+              </a:schemeClr>
+            </a:gs>
+          </a:gsLst>
+          <a:lin ang="5400000" scaled="0"/>
+        </a:gradFill>
+        <a:gradFill rotWithShape="1">
+          <a:gsLst>
+            <a:gs pos="0">
+              <a:schemeClr val="phClr">
+                <a:satMod val="103000"/>
+                <a:lumMod val="102000"/>
+                <a:tint val="94000"/>
+              </a:schemeClr>
+            </a:gs>
+            <a:gs pos="50000">
+              <a:schemeClr val="phClr">
+                <a:satMod val="110000"/>
+                <a:lumMod val="100000"/>
+                <a:shade val="100000"/>
+              </a:schemeClr>
+            </a:gs>
+            <a:gs pos="100000">
+              <a:schemeClr val="phClr">
+                <a:lumMod val="99000"/>
+                <a:satMod val="120000"/>
+                <a:shade val="78000"/>
+              </a:schemeClr>
+            </a:gs>
+          </a:gsLst>
+          <a:lin ang="5400000" scaled="0"/>
+        </a:gradFill>
+      </a:fillStyleLst>
+      <a:lnStyleLst>
+        <a:ln w="6350" cap="flat" cmpd="sng" algn="ctr">
+          <a:solidFill>
+            <a:schemeClr val="phClr"/>
+          </a:solidFill>
+          <a:prstDash val="solid"/>
+          <a:miter lim="800000"/>
+        </a:ln>
+        <a:ln w="12700" cap="flat" cmpd="sng" algn="ctr">
+          <a:solidFill>
+            <a:schemeClr val="phClr"/>
+          </a:solidFill>
+          <a:prstDash val="solid"/>
+          <a:miter lim="800000"/>
+        </a:ln>
+        <a:ln w="19050" cap="flat" cmpd="sng" algn="ctr">
+          <a:solidFill>
+            <a:schemeClr val="phClr"/>
+          </a:solidFill>
+          <a:prstDash val="solid"/>
+          <a:miter lim="800000"/>
+        </a:ln>
+      </a:lnStyleLst>
+      <a:effectStyleLst>
+        <a:effectStyle>
+          <a:effectLst/>
+        </a:effectStyle>
+        <a:effectStyle>
+          <a:effectLst/>
+        </a:effectStyle>
+        <a:effectStyle>
+          <a:effectLst>
+            <a:outerShdw blurRad="57150" dist="19050" dir="5400000" algn="ctr" rotWithShape="0">
+              <a:srgbClr val="000000">
+                <a:alpha val="63000"/>
+              </a:srgbClr>
+            </a:outerShdw>
+          </a:effectLst>
+        </a:effectStyle>
+      </a:effectStyleLst>
+      <a:bgFillStyleLst>
+        <a:solidFill>
+          <a:schemeClr val="phClr"/>
+        </a:solidFill>
+        <a:solidFill>
+          <a:schemeClr val="phClr">
+            <a:tint val="95000"/>
+            <a:satMod val="170000"/>
+          </a:schemeClr>
+        </a:solidFill>
+        <a:gradFill rotWithShape="1">
+          <a:gsLst>
+            <a:gs pos="0">
+              <a:schemeClr val="phClr">
+                <a:tint val="93000"/>
+                <a:satMod val="150000"/>
+                <a:shade val="98000"/>
+                <a:lumMod val="102000"/>
+              </a:schemeClr>
+            </a:gs>
+            <a:gs pos="50000">
+              <a:schemeClr val="phClr">
+                <a:tint val="98000"/>
+                <a:satMod val="130000"/>
+                <a:shade val="90000"/>
+                <a:lumMod val="103000"/>
+              </a:schemeClr>
+            </a:gs>
+            <a:gs pos="100000">
+              <a:schemeClr val="phClr">
+                <a:shade val="63000"/>
+                <a:satMod val="120000"/>
+              </a:schemeClr>
+            </a:gs>
+          </a:gsLst>
+          <a:lin ang="5400000" scaled="0"/>
+        </a:gradFill>
+      </a:bgFillStyleLst>
+    </a:fmtScheme>
+  </a:themeElements>
+  <a:objectDefaults/>
+  <a:extraClrSchemeLst/>
+  <a:extLst>
+    <a:ext uri="{05A4C25C-085E-4340-85A3-A5531E510DB2}">
+      <thm15:themeFamily xmlns:thm15="http://schemas.microsoft.com/office/thememl/2012/main" name="Office Theme" id="{62F939B6-93AF-4DB8-9C6B-D6C7DFDC589F}" vid="{4A3C46E8-61CC-4603-A589-7422A47A8E4A}"/>
+    </a:ext>
+  </a:extLst>
+</a:theme>
+</file>
+
+<file path=ppt/theme/theme2.xml><?xml version="1.0" encoding="utf-8"?>
+<a:theme xmlns:a="http://schemas.openxmlformats.org/drawingml/2006/main" name="Office 主题​​">
+  <a:themeElements>
     <a:clrScheme name="Office">
       <a:dk1>
         <a:sysClr val="windowText" lastClr="000000"/>
@@ -3994,7 +4308,7 @@
         <a:srgbClr val="E7E6E6"/>
       </a:lt2>
       <a:accent1>
-        <a:srgbClr val="4472C4"/>
+        <a:srgbClr val="5B9BD5"/>
       </a:accent1>
       <a:accent2>
         <a:srgbClr val="ED7D31"/>
@@ -4006,7 +4320,7 @@
         <a:srgbClr val="FFC000"/>
       </a:accent4>
       <a:accent5>
-        <a:srgbClr val="5B9BD5"/>
+        <a:srgbClr val="4472C4"/>
       </a:accent5>
       <a:accent6>
         <a:srgbClr val="70AD47"/>
@@ -4053,23 +4367,6 @@
         <a:font script="Viet" typeface="Times New Roman"/>
         <a:font script="Uigh" typeface="Microsoft Uighur"/>
         <a:font script="Geor" typeface="Sylfaen"/>
-        <a:font script="Armn" typeface="Arial"/>
-        <a:font script="Bugi" typeface="Leelawadee UI"/>
-        <a:font script="Bopo" typeface="Microsoft JhengHei"/>
-        <a:font script="Java" typeface="Javanese Text"/>
-        <a:font script="Lisu" typeface="Segoe UI"/>
-        <a:font script="Mymr" typeface="Myanmar Text"/>
-        <a:font script="Nkoo" typeface="Ebrima"/>
-        <a:font script="Olck" typeface="Nirmala UI"/>
-        <a:font script="Osma" typeface="Ebrima"/>
-        <a:font script="Phag" typeface="Phagspa"/>
-        <a:font script="Syrn" typeface="Estrangelo Edessa"/>
-        <a:font script="Syrj" typeface="Estrangelo Edessa"/>
-        <a:font script="Syre" typeface="Estrangelo Edessa"/>
-        <a:font script="Sora" typeface="Nirmala UI"/>
-        <a:font script="Tale" typeface="Microsoft Tai Le"/>
-        <a:font script="Talu" typeface="Microsoft New Tai Lue"/>
-        <a:font script="Tfng" typeface="Ebrima"/>
       </a:majorFont>
       <a:minorFont>
         <a:latin typeface="等线" panose="020F0502020204030204"/>
@@ -4105,23 +4402,6 @@
         <a:font script="Viet" typeface="Arial"/>
         <a:font script="Uigh" typeface="Microsoft Uighur"/>
         <a:font script="Geor" typeface="Sylfaen"/>
-        <a:font script="Armn" typeface="Arial"/>
-        <a:font script="Bugi" typeface="Leelawadee UI"/>
-        <a:font script="Bopo" typeface="Microsoft JhengHei"/>
-        <a:font script="Java" typeface="Javanese Text"/>
-        <a:font script="Lisu" typeface="Segoe UI"/>
-        <a:font script="Mymr" typeface="Myanmar Text"/>
-        <a:font script="Nkoo" typeface="Ebrima"/>
-        <a:font script="Olck" typeface="Nirmala UI"/>
-        <a:font script="Osma" typeface="Ebrima"/>
-        <a:font script="Phag" typeface="Phagspa"/>
-        <a:font script="Syrn" typeface="Estrangelo Edessa"/>
-        <a:font script="Syrj" typeface="Estrangelo Edessa"/>
-        <a:font script="Syre" typeface="Estrangelo Edessa"/>
-        <a:font script="Sora" typeface="Nirmala UI"/>
-        <a:font script="Tale" typeface="Microsoft Tai Le"/>
-        <a:font script="Talu" typeface="Microsoft New Tai Lue"/>
-        <a:font script="Tfng" typeface="Ebrima"/>
       </a:minorFont>
     </a:fontScheme>
     <a:fmtScheme name="Office">

</xml_diff>